<commit_message>
Final submission: README for judges, video link, deck, disclosure
</commit_message>
<xml_diff>
--- a/submission/TIET_TapTrace.pptx
+++ b/submission/TIET_TapTrace.pptx
@@ -300,7 +300,7 @@
             </c:spPr>
             <c:extLst>
               <c:ext xmlns:c16="http://schemas.microsoft.com/office/drawing/2014/chart" uri="{C3380CC4-5D6E-409C-BE32-E72D297353CC}">
-                <c16:uniqueId val="{00000001-701E-4CF4-8602-88D1BC076643}"/>
+                <c16:uniqueId val="{00000001-2B4E-40EE-A626-FF55BF1396FF}"/>
               </c:ext>
             </c:extLst>
           </c:dPt>
@@ -315,7 +315,7 @@
             </c:spPr>
             <c:extLst>
               <c:ext xmlns:c16="http://schemas.microsoft.com/office/drawing/2014/chart" uri="{C3380CC4-5D6E-409C-BE32-E72D297353CC}">
-                <c16:uniqueId val="{00000003-701E-4CF4-8602-88D1BC076643}"/>
+                <c16:uniqueId val="{00000003-2B4E-40EE-A626-FF55BF1396FF}"/>
               </c:ext>
             </c:extLst>
           </c:dPt>
@@ -330,7 +330,7 @@
             </c:spPr>
             <c:extLst>
               <c:ext xmlns:c16="http://schemas.microsoft.com/office/drawing/2014/chart" uri="{C3380CC4-5D6E-409C-BE32-E72D297353CC}">
-                <c16:uniqueId val="{00000005-701E-4CF4-8602-88D1BC076643}"/>
+                <c16:uniqueId val="{00000005-2B4E-40EE-A626-FF55BF1396FF}"/>
               </c:ext>
             </c:extLst>
           </c:dPt>
@@ -345,7 +345,7 @@
             </c:spPr>
             <c:extLst>
               <c:ext xmlns:c16="http://schemas.microsoft.com/office/drawing/2014/chart" uri="{C3380CC4-5D6E-409C-BE32-E72D297353CC}">
-                <c16:uniqueId val="{00000007-701E-4CF4-8602-88D1BC076643}"/>
+                <c16:uniqueId val="{00000007-2B4E-40EE-A626-FF55BF1396FF}"/>
               </c:ext>
             </c:extLst>
           </c:dPt>
@@ -429,7 +429,7 @@
           </c:val>
           <c:extLst>
             <c:ext xmlns:c16="http://schemas.microsoft.com/office/drawing/2014/chart" uri="{C3380CC4-5D6E-409C-BE32-E72D297353CC}">
-              <c16:uniqueId val="{00000008-701E-4CF4-8602-88D1BC076643}"/>
+              <c16:uniqueId val="{00000008-2B4E-40EE-A626-FF55BF1396FF}"/>
             </c:ext>
           </c:extLst>
         </c:ser>
@@ -580,7 +580,7 @@
             </c:spPr>
             <c:extLst>
               <c:ext xmlns:c16="http://schemas.microsoft.com/office/drawing/2014/chart" uri="{C3380CC4-5D6E-409C-BE32-E72D297353CC}">
-                <c16:uniqueId val="{00000001-B6CD-4CB9-B66C-1C000C5A2490}"/>
+                <c16:uniqueId val="{00000001-D58B-4FB7-B73A-0C666BE55702}"/>
               </c:ext>
             </c:extLst>
           </c:dPt>
@@ -595,7 +595,7 @@
             </c:spPr>
             <c:extLst>
               <c:ext xmlns:c16="http://schemas.microsoft.com/office/drawing/2014/chart" uri="{C3380CC4-5D6E-409C-BE32-E72D297353CC}">
-                <c16:uniqueId val="{00000003-B6CD-4CB9-B66C-1C000C5A2490}"/>
+                <c16:uniqueId val="{00000003-D58B-4FB7-B73A-0C666BE55702}"/>
               </c:ext>
             </c:extLst>
           </c:dPt>
@@ -610,7 +610,7 @@
             </c:spPr>
             <c:extLst>
               <c:ext xmlns:c16="http://schemas.microsoft.com/office/drawing/2014/chart" uri="{C3380CC4-5D6E-409C-BE32-E72D297353CC}">
-                <c16:uniqueId val="{00000005-B6CD-4CB9-B66C-1C000C5A2490}"/>
+                <c16:uniqueId val="{00000005-D58B-4FB7-B73A-0C666BE55702}"/>
               </c:ext>
             </c:extLst>
           </c:dPt>
@@ -625,7 +625,7 @@
             </c:spPr>
             <c:extLst>
               <c:ext xmlns:c16="http://schemas.microsoft.com/office/drawing/2014/chart" uri="{C3380CC4-5D6E-409C-BE32-E72D297353CC}">
-                <c16:uniqueId val="{00000007-B6CD-4CB9-B66C-1C000C5A2490}"/>
+                <c16:uniqueId val="{00000007-D58B-4FB7-B73A-0C666BE55702}"/>
               </c:ext>
             </c:extLst>
           </c:dPt>
@@ -709,7 +709,7 @@
           </c:val>
           <c:extLst>
             <c:ext xmlns:c16="http://schemas.microsoft.com/office/drawing/2014/chart" uri="{C3380CC4-5D6E-409C-BE32-E72D297353CC}">
-              <c16:uniqueId val="{00000008-B6CD-4CB9-B66C-1C000C5A2490}"/>
+              <c16:uniqueId val="{00000008-D58B-4FB7-B73A-0C666BE55702}"/>
             </c:ext>
           </c:extLst>
         </c:ser>
@@ -931,7 +931,7 @@
               </c14:invertSolidFillFmt>
             </c:ext>
             <c:ext xmlns:c16="http://schemas.microsoft.com/office/drawing/2014/chart" uri="{C3380CC4-5D6E-409C-BE32-E72D297353CC}">
-              <c16:uniqueId val="{00000000-EBD8-4513-BC50-84319260966E}"/>
+              <c16:uniqueId val="{00000000-BC00-40E4-B368-BED54B2AD553}"/>
             </c:ext>
           </c:extLst>
         </c:ser>
@@ -1032,7 +1032,7 @@
               </c14:invertSolidFillFmt>
             </c:ext>
             <c:ext xmlns:c16="http://schemas.microsoft.com/office/drawing/2014/chart" uri="{C3380CC4-5D6E-409C-BE32-E72D297353CC}">
-              <c16:uniqueId val="{00000001-EBD8-4513-BC50-84319260966E}"/>
+              <c16:uniqueId val="{00000001-BC00-40E4-B368-BED54B2AD553}"/>
             </c:ext>
           </c:extLst>
         </c:ser>
@@ -14735,8 +14735,8 @@
         </p:nvSpPr>
         <p:spPr>
           <a:xfrm>
-            <a:off x="685800" y="6236208"/>
-            <a:ext cx="10835640" cy="274320"/>
+            <a:off x="685800" y="6217920"/>
+            <a:ext cx="10835640" cy="457200"/>
           </a:xfrm>
           <a:prstGeom prst="rect">
             <a:avLst/>
@@ -14749,15 +14749,31 @@
           </a:bodyPr>
           <a:lstStyle/>
           <a:p>
+            <a:pPr algn="l">
+              <a:spcAft>
+                <a:spcPts val="300"/>
+              </a:spcAft>
+            </a:pPr>
+            <a:r>
+              <a:rPr sz="850" b="0" i="0" spc="120">
+                <a:solidFill>
+                  <a:srgbClr val="CFC6BA"/>
+                </a:solidFill>
+                <a:latin typeface="Segoe UI"/>
+              </a:rPr>
+              <a:t>THEME ID 02   |   TEAM TAPTRACE   |   THAPAR INSTITUTE OF ENGINEERING &amp; TECHNOLOGY   |   ARNAV JOSHI · ajoshi4_be23@thapar.edu</a:t>
+            </a:r>
+          </a:p>
+          <a:p>
             <a:pPr algn="l"/>
             <a:r>
               <a:rPr sz="850" b="0" i="0" spc="120">
                 <a:solidFill>
-                  <a:srgbClr val="CFC6BA"/>
+                  <a:srgbClr val="F2B66D"/>
                 </a:solidFill>
                 <a:latin typeface="Segoe UI"/>
               </a:rPr>
-              <a:t>THEME ID 02   |   TEAM TAPTRACE   |   THAPAR INSTITUTE OF ENGINEERING &amp; TECHNOLOGY   |   ARNAV JOSHI · ajoshi4_be23@thapar.edu   |   github.com/Arnav020/Tap-Trace   |   LIVE taptrace.onrender.com</a:t>
+              <a:t>CODE  github.com/Arnav020/Tap-Trace   |   LIVE DEMO  taptrace.onrender.com</a:t>
             </a:r>
           </a:p>
         </p:txBody>
@@ -14767,7 +14783,7 @@
           <p:cNvPr id="3" name="icon">
             <a:extLst>
               <a:ext uri="{FF2B5EF4-FFF2-40B4-BE49-F238E27FC236}">
-                <a16:creationId xmlns:a16="http://schemas.microsoft.com/office/drawing/2014/main" id="{6704C548-27D1-1BCE-2AA4-F35363E848DF}"/>
+                <a16:creationId xmlns:a16="http://schemas.microsoft.com/office/drawing/2014/main" id="{0B583B85-FD95-F7F8-23CD-3DBFE4FFD971}"/>
               </a:ext>
             </a:extLst>
           </p:cNvPr>
@@ -14803,7 +14819,7 @@
           <p:cNvPr id="5" name="icon">
             <a:extLst>
               <a:ext uri="{FF2B5EF4-FFF2-40B4-BE49-F238E27FC236}">
-                <a16:creationId xmlns:a16="http://schemas.microsoft.com/office/drawing/2014/main" id="{842BB945-A96E-F71C-43E6-6525DB53991C}"/>
+                <a16:creationId xmlns:a16="http://schemas.microsoft.com/office/drawing/2014/main" id="{ACC8B534-578D-981F-2D0F-ADA4E7A37EDD}"/>
               </a:ext>
             </a:extLst>
           </p:cNvPr>
@@ -14839,7 +14855,7 @@
           <p:cNvPr id="7" name="icon">
             <a:extLst>
               <a:ext uri="{FF2B5EF4-FFF2-40B4-BE49-F238E27FC236}">
-                <a16:creationId xmlns:a16="http://schemas.microsoft.com/office/drawing/2014/main" id="{9CC48CD0-1FEC-D66B-8095-6784C2AEFE44}"/>
+                <a16:creationId xmlns:a16="http://schemas.microsoft.com/office/drawing/2014/main" id="{D78F132A-64FB-ECFE-90B8-72358678ACAA}"/>
               </a:ext>
             </a:extLst>
           </p:cNvPr>
@@ -14875,7 +14891,7 @@
           <p:cNvPr id="9" name="icon">
             <a:extLst>
               <a:ext uri="{FF2B5EF4-FFF2-40B4-BE49-F238E27FC236}">
-                <a16:creationId xmlns:a16="http://schemas.microsoft.com/office/drawing/2014/main" id="{6CA15420-DE8F-7017-BE0C-807F13ACCBF7}"/>
+                <a16:creationId xmlns:a16="http://schemas.microsoft.com/office/drawing/2014/main" id="{5A850024-1775-6627-56F3-20CD02EF6377}"/>
               </a:ext>
             </a:extLst>
           </p:cNvPr>
@@ -17013,7 +17029,7 @@
           <p:cNvPr id="3" name="icon">
             <a:extLst>
               <a:ext uri="{FF2B5EF4-FFF2-40B4-BE49-F238E27FC236}">
-                <a16:creationId xmlns:a16="http://schemas.microsoft.com/office/drawing/2014/main" id="{EAB1DEC9-61A5-3477-0CBF-6A9F101D0926}"/>
+                <a16:creationId xmlns:a16="http://schemas.microsoft.com/office/drawing/2014/main" id="{C86DD8C8-2284-6FA5-CA59-D7811B4A422E}"/>
               </a:ext>
             </a:extLst>
           </p:cNvPr>
@@ -17049,7 +17065,7 @@
           <p:cNvPr id="5" name="icon">
             <a:extLst>
               <a:ext uri="{FF2B5EF4-FFF2-40B4-BE49-F238E27FC236}">
-                <a16:creationId xmlns:a16="http://schemas.microsoft.com/office/drawing/2014/main" id="{D440D650-1DDD-3698-9DC9-EA23D69FD158}"/>
+                <a16:creationId xmlns:a16="http://schemas.microsoft.com/office/drawing/2014/main" id="{85F91D8E-5E9C-3C34-9409-2728C553F31E}"/>
               </a:ext>
             </a:extLst>
           </p:cNvPr>
@@ -17085,7 +17101,7 @@
           <p:cNvPr id="7" name="icon">
             <a:extLst>
               <a:ext uri="{FF2B5EF4-FFF2-40B4-BE49-F238E27FC236}">
-                <a16:creationId xmlns:a16="http://schemas.microsoft.com/office/drawing/2014/main" id="{A6FEB0E5-17B1-5DDF-2CE0-E3CE36C671E8}"/>
+                <a16:creationId xmlns:a16="http://schemas.microsoft.com/office/drawing/2014/main" id="{B4A7C590-028B-75BA-6622-05F0502FCFBE}"/>
               </a:ext>
             </a:extLst>
           </p:cNvPr>
@@ -17121,7 +17137,7 @@
           <p:cNvPr id="9" name="icon">
             <a:extLst>
               <a:ext uri="{FF2B5EF4-FFF2-40B4-BE49-F238E27FC236}">
-                <a16:creationId xmlns:a16="http://schemas.microsoft.com/office/drawing/2014/main" id="{6682AA99-0A5E-C918-6AC5-7129B21B6195}"/>
+                <a16:creationId xmlns:a16="http://schemas.microsoft.com/office/drawing/2014/main" id="{27B56703-5ECD-43EC-75A3-F839DC024009}"/>
               </a:ext>
             </a:extLst>
           </p:cNvPr>
@@ -17157,7 +17173,7 @@
           <p:cNvPr id="11" name="icon">
             <a:extLst>
               <a:ext uri="{FF2B5EF4-FFF2-40B4-BE49-F238E27FC236}">
-                <a16:creationId xmlns:a16="http://schemas.microsoft.com/office/drawing/2014/main" id="{FD0E5D60-0991-FB37-0520-8D5AA4A0DBCA}"/>
+                <a16:creationId xmlns:a16="http://schemas.microsoft.com/office/drawing/2014/main" id="{2470324C-08FC-F119-7C7E-C1F596CC31E3}"/>
               </a:ext>
             </a:extLst>
           </p:cNvPr>
@@ -17193,7 +17209,7 @@
           <p:cNvPr id="13" name="icon">
             <a:extLst>
               <a:ext uri="{FF2B5EF4-FFF2-40B4-BE49-F238E27FC236}">
-                <a16:creationId xmlns:a16="http://schemas.microsoft.com/office/drawing/2014/main" id="{B830816E-F056-EFF3-5953-2CC79AEA55ED}"/>
+                <a16:creationId xmlns:a16="http://schemas.microsoft.com/office/drawing/2014/main" id="{7E23C3B3-8BE7-E7E1-BA2C-00AEF28A7F56}"/>
               </a:ext>
             </a:extLst>
           </p:cNvPr>
@@ -17229,7 +17245,7 @@
           <p:cNvPr id="15" name="icon">
             <a:extLst>
               <a:ext uri="{FF2B5EF4-FFF2-40B4-BE49-F238E27FC236}">
-                <a16:creationId xmlns:a16="http://schemas.microsoft.com/office/drawing/2014/main" id="{AE22BBF6-D79A-95AD-4D39-C1B5D220F046}"/>
+                <a16:creationId xmlns:a16="http://schemas.microsoft.com/office/drawing/2014/main" id="{E327151B-FDD7-2D17-0F50-78D0983E8CA8}"/>
               </a:ext>
             </a:extLst>
           </p:cNvPr>
@@ -17265,7 +17281,7 @@
           <p:cNvPr id="17" name="icon">
             <a:extLst>
               <a:ext uri="{FF2B5EF4-FFF2-40B4-BE49-F238E27FC236}">
-                <a16:creationId xmlns:a16="http://schemas.microsoft.com/office/drawing/2014/main" id="{4B5762B9-2498-25D4-B211-C2E82C4AD107}"/>
+                <a16:creationId xmlns:a16="http://schemas.microsoft.com/office/drawing/2014/main" id="{9E9EB41C-9D6F-F693-D67F-B3574A21CF04}"/>
               </a:ext>
             </a:extLst>
           </p:cNvPr>
@@ -17301,7 +17317,7 @@
           <p:cNvPr id="19" name="icon">
             <a:extLst>
               <a:ext uri="{FF2B5EF4-FFF2-40B4-BE49-F238E27FC236}">
-                <a16:creationId xmlns:a16="http://schemas.microsoft.com/office/drawing/2014/main" id="{BDE62337-E7DB-E593-DF68-CA9234B2A622}"/>
+                <a16:creationId xmlns:a16="http://schemas.microsoft.com/office/drawing/2014/main" id="{CFCB1AA5-EBCE-BDFA-8C57-6130F7904C51}"/>
               </a:ext>
             </a:extLst>
           </p:cNvPr>
@@ -17337,7 +17353,7 @@
           <p:cNvPr id="21" name="icon">
             <a:extLst>
               <a:ext uri="{FF2B5EF4-FFF2-40B4-BE49-F238E27FC236}">
-                <a16:creationId xmlns:a16="http://schemas.microsoft.com/office/drawing/2014/main" id="{24BDB4A0-998C-DE16-2E5D-480C20C1D6A5}"/>
+                <a16:creationId xmlns:a16="http://schemas.microsoft.com/office/drawing/2014/main" id="{B37A3333-604C-8574-D1AD-A16D706B2F0C}"/>
               </a:ext>
             </a:extLst>
           </p:cNvPr>
@@ -17373,7 +17389,7 @@
           <p:cNvPr id="23" name="icon">
             <a:extLst>
               <a:ext uri="{FF2B5EF4-FFF2-40B4-BE49-F238E27FC236}">
-                <a16:creationId xmlns:a16="http://schemas.microsoft.com/office/drawing/2014/main" id="{458BBE05-A489-FCB2-918F-39AA584D40D9}"/>
+                <a16:creationId xmlns:a16="http://schemas.microsoft.com/office/drawing/2014/main" id="{33B4C9F2-A2B1-672D-A676-625674D7D521}"/>
               </a:ext>
             </a:extLst>
           </p:cNvPr>
@@ -17409,7 +17425,7 @@
           <p:cNvPr id="25" name="icon">
             <a:extLst>
               <a:ext uri="{FF2B5EF4-FFF2-40B4-BE49-F238E27FC236}">
-                <a16:creationId xmlns:a16="http://schemas.microsoft.com/office/drawing/2014/main" id="{AB2DDA40-710D-6EAA-9588-2E7C7121ED24}"/>
+                <a16:creationId xmlns:a16="http://schemas.microsoft.com/office/drawing/2014/main" id="{9EA8116D-7B57-9ABD-94BA-04284B41730F}"/>
               </a:ext>
             </a:extLst>
           </p:cNvPr>
@@ -17445,7 +17461,7 @@
           <p:cNvPr id="27" name="icon">
             <a:extLst>
               <a:ext uri="{FF2B5EF4-FFF2-40B4-BE49-F238E27FC236}">
-                <a16:creationId xmlns:a16="http://schemas.microsoft.com/office/drawing/2014/main" id="{CDFA0671-E8E8-5395-0A66-FE96B4603041}"/>
+                <a16:creationId xmlns:a16="http://schemas.microsoft.com/office/drawing/2014/main" id="{16F17542-B93A-03A2-8137-0BF896D62098}"/>
               </a:ext>
             </a:extLst>
           </p:cNvPr>
@@ -17481,7 +17497,7 @@
           <p:cNvPr id="29" name="icon">
             <a:extLst>
               <a:ext uri="{FF2B5EF4-FFF2-40B4-BE49-F238E27FC236}">
-                <a16:creationId xmlns:a16="http://schemas.microsoft.com/office/drawing/2014/main" id="{9A9AC4A7-08DD-AC5C-0D5D-A592B1BFA43C}"/>
+                <a16:creationId xmlns:a16="http://schemas.microsoft.com/office/drawing/2014/main" id="{862AD4DD-6974-8840-8C8F-D088388419AE}"/>
               </a:ext>
             </a:extLst>
           </p:cNvPr>
@@ -18594,7 +18610,7 @@
                 </a:solidFill>
                 <a:latin typeface="Segoe UI"/>
               </a:rPr>
-              <a:t>YouTube / Drive link in the submission form</a:t>
+              <a:t>https://youtu.be/72Otbd-1QvM</a:t>
             </a:r>
           </a:p>
         </p:txBody>
@@ -19348,7 +19364,7 @@
           <p:cNvPr id="3" name="icon">
             <a:extLst>
               <a:ext uri="{FF2B5EF4-FFF2-40B4-BE49-F238E27FC236}">
-                <a16:creationId xmlns:a16="http://schemas.microsoft.com/office/drawing/2014/main" id="{9FED3075-52E7-11DE-7CDA-69D7A7AD4D09}"/>
+                <a16:creationId xmlns:a16="http://schemas.microsoft.com/office/drawing/2014/main" id="{33A2B87F-BDF0-1FCA-A36E-5413A44713E4}"/>
               </a:ext>
             </a:extLst>
           </p:cNvPr>
@@ -19384,7 +19400,7 @@
           <p:cNvPr id="5" name="icon">
             <a:extLst>
               <a:ext uri="{FF2B5EF4-FFF2-40B4-BE49-F238E27FC236}">
-                <a16:creationId xmlns:a16="http://schemas.microsoft.com/office/drawing/2014/main" id="{2DF68F99-EE98-C718-447C-CC139AACCB27}"/>
+                <a16:creationId xmlns:a16="http://schemas.microsoft.com/office/drawing/2014/main" id="{F49B5164-73EC-4DA1-FE1B-47C2F61DE89E}"/>
               </a:ext>
             </a:extLst>
           </p:cNvPr>
@@ -19420,7 +19436,7 @@
           <p:cNvPr id="7" name="icon">
             <a:extLst>
               <a:ext uri="{FF2B5EF4-FFF2-40B4-BE49-F238E27FC236}">
-                <a16:creationId xmlns:a16="http://schemas.microsoft.com/office/drawing/2014/main" id="{B09CD20C-D145-386E-29A4-C3A6EF4B6F7D}"/>
+                <a16:creationId xmlns:a16="http://schemas.microsoft.com/office/drawing/2014/main" id="{248165E2-8DC3-7EBA-3546-48479EC7B182}"/>
               </a:ext>
             </a:extLst>
           </p:cNvPr>
@@ -19456,7 +19472,7 @@
           <p:cNvPr id="9" name="icon">
             <a:extLst>
               <a:ext uri="{FF2B5EF4-FFF2-40B4-BE49-F238E27FC236}">
-                <a16:creationId xmlns:a16="http://schemas.microsoft.com/office/drawing/2014/main" id="{22BC7D2E-7ABD-8D21-A6B2-219F17467B55}"/>
+                <a16:creationId xmlns:a16="http://schemas.microsoft.com/office/drawing/2014/main" id="{00C21327-E81D-A50B-501E-7A26E75DDB96}"/>
               </a:ext>
             </a:extLst>
           </p:cNvPr>
@@ -19492,7 +19508,7 @@
           <p:cNvPr id="11" name="icon">
             <a:extLst>
               <a:ext uri="{FF2B5EF4-FFF2-40B4-BE49-F238E27FC236}">
-                <a16:creationId xmlns:a16="http://schemas.microsoft.com/office/drawing/2014/main" id="{11622203-5B5E-1838-AB44-61FD08E21682}"/>
+                <a16:creationId xmlns:a16="http://schemas.microsoft.com/office/drawing/2014/main" id="{21D42B11-957B-4337-596F-9E1CB494896C}"/>
               </a:ext>
             </a:extLst>
           </p:cNvPr>
@@ -19528,7 +19544,7 @@
           <p:cNvPr id="13" name="icon">
             <a:extLst>
               <a:ext uri="{FF2B5EF4-FFF2-40B4-BE49-F238E27FC236}">
-                <a16:creationId xmlns:a16="http://schemas.microsoft.com/office/drawing/2014/main" id="{9FBCC454-4037-6FB2-DF66-4D4EE5C800AC}"/>
+                <a16:creationId xmlns:a16="http://schemas.microsoft.com/office/drawing/2014/main" id="{307C50B6-7660-B22E-5978-3A434505A801}"/>
               </a:ext>
             </a:extLst>
           </p:cNvPr>
@@ -22786,7 +22802,7 @@
           <p:cNvPr id="3" name="icon">
             <a:extLst>
               <a:ext uri="{FF2B5EF4-FFF2-40B4-BE49-F238E27FC236}">
-                <a16:creationId xmlns:a16="http://schemas.microsoft.com/office/drawing/2014/main" id="{990DFEF0-117A-964A-8A3E-8772C98F0600}"/>
+                <a16:creationId xmlns:a16="http://schemas.microsoft.com/office/drawing/2014/main" id="{C5B66C33-6D62-EF9C-D830-CC8D9AB9B11D}"/>
               </a:ext>
             </a:extLst>
           </p:cNvPr>
@@ -22822,7 +22838,7 @@
           <p:cNvPr id="5" name="icon">
             <a:extLst>
               <a:ext uri="{FF2B5EF4-FFF2-40B4-BE49-F238E27FC236}">
-                <a16:creationId xmlns:a16="http://schemas.microsoft.com/office/drawing/2014/main" id="{8888CAE2-5C6C-69C9-999D-EE285A7D7CDB}"/>
+                <a16:creationId xmlns:a16="http://schemas.microsoft.com/office/drawing/2014/main" id="{85B3B52B-B93A-02F4-5CDF-75A95661D457}"/>
               </a:ext>
             </a:extLst>
           </p:cNvPr>
@@ -22858,7 +22874,7 @@
           <p:cNvPr id="7" name="icon">
             <a:extLst>
               <a:ext uri="{FF2B5EF4-FFF2-40B4-BE49-F238E27FC236}">
-                <a16:creationId xmlns:a16="http://schemas.microsoft.com/office/drawing/2014/main" id="{EB465FC9-6BE6-3A1E-C328-F1C078999AFC}"/>
+                <a16:creationId xmlns:a16="http://schemas.microsoft.com/office/drawing/2014/main" id="{4B95E9FC-3EAF-DD18-7E0F-B9EF331F3FBD}"/>
               </a:ext>
             </a:extLst>
           </p:cNvPr>
@@ -22894,7 +22910,7 @@
           <p:cNvPr id="9" name="icon">
             <a:extLst>
               <a:ext uri="{FF2B5EF4-FFF2-40B4-BE49-F238E27FC236}">
-                <a16:creationId xmlns:a16="http://schemas.microsoft.com/office/drawing/2014/main" id="{9E79063D-7CE2-D7CF-68EE-BF8863F50765}"/>
+                <a16:creationId xmlns:a16="http://schemas.microsoft.com/office/drawing/2014/main" id="{12A2038B-530A-4467-1E68-8F5C8A8BA8F2}"/>
               </a:ext>
             </a:extLst>
           </p:cNvPr>
@@ -22930,7 +22946,7 @@
           <p:cNvPr id="11" name="icon">
             <a:extLst>
               <a:ext uri="{FF2B5EF4-FFF2-40B4-BE49-F238E27FC236}">
-                <a16:creationId xmlns:a16="http://schemas.microsoft.com/office/drawing/2014/main" id="{6F667CD0-B12F-7B3A-0B24-882AE3FF6469}"/>
+                <a16:creationId xmlns:a16="http://schemas.microsoft.com/office/drawing/2014/main" id="{65DFEF2B-9800-6933-5EF9-7C6D375D5393}"/>
               </a:ext>
             </a:extLst>
           </p:cNvPr>
@@ -25524,7 +25540,7 @@
           <p:cNvPr id="3" name="icon">
             <a:extLst>
               <a:ext uri="{FF2B5EF4-FFF2-40B4-BE49-F238E27FC236}">
-                <a16:creationId xmlns:a16="http://schemas.microsoft.com/office/drawing/2014/main" id="{BF826D7E-4CC9-6113-5BE8-BFCAB63CAABA}"/>
+                <a16:creationId xmlns:a16="http://schemas.microsoft.com/office/drawing/2014/main" id="{17B2B313-F2FD-AE1C-E451-C85D65BA1184}"/>
               </a:ext>
             </a:extLst>
           </p:cNvPr>
@@ -25560,7 +25576,7 @@
           <p:cNvPr id="5" name="icon">
             <a:extLst>
               <a:ext uri="{FF2B5EF4-FFF2-40B4-BE49-F238E27FC236}">
-                <a16:creationId xmlns:a16="http://schemas.microsoft.com/office/drawing/2014/main" id="{BECC0211-7894-7794-3DA8-65D2199BFC85}"/>
+                <a16:creationId xmlns:a16="http://schemas.microsoft.com/office/drawing/2014/main" id="{F31B72BB-C61A-F840-AE4F-1A960F405B2E}"/>
               </a:ext>
             </a:extLst>
           </p:cNvPr>
@@ -25596,7 +25612,7 @@
           <p:cNvPr id="7" name="icon">
             <a:extLst>
               <a:ext uri="{FF2B5EF4-FFF2-40B4-BE49-F238E27FC236}">
-                <a16:creationId xmlns:a16="http://schemas.microsoft.com/office/drawing/2014/main" id="{106B683B-F8D6-AF9A-0655-268BFE9B367D}"/>
+                <a16:creationId xmlns:a16="http://schemas.microsoft.com/office/drawing/2014/main" id="{CEDC2F07-CF34-DFA5-BFAD-AF33EC800B38}"/>
               </a:ext>
             </a:extLst>
           </p:cNvPr>
@@ -25632,7 +25648,7 @@
           <p:cNvPr id="9" name="icon">
             <a:extLst>
               <a:ext uri="{FF2B5EF4-FFF2-40B4-BE49-F238E27FC236}">
-                <a16:creationId xmlns:a16="http://schemas.microsoft.com/office/drawing/2014/main" id="{366CBD83-6237-CD8A-5CD8-51E95F41553D}"/>
+                <a16:creationId xmlns:a16="http://schemas.microsoft.com/office/drawing/2014/main" id="{77080900-6D66-EB06-F87E-166C7823902E}"/>
               </a:ext>
             </a:extLst>
           </p:cNvPr>
@@ -25668,7 +25684,7 @@
           <p:cNvPr id="11" name="icon">
             <a:extLst>
               <a:ext uri="{FF2B5EF4-FFF2-40B4-BE49-F238E27FC236}">
-                <a16:creationId xmlns:a16="http://schemas.microsoft.com/office/drawing/2014/main" id="{A3030805-8920-FF43-297C-04A8BEB07EDA}"/>
+                <a16:creationId xmlns:a16="http://schemas.microsoft.com/office/drawing/2014/main" id="{386948EC-828B-D5EB-FE38-83601FA602A1}"/>
               </a:ext>
             </a:extLst>
           </p:cNvPr>
@@ -25704,7 +25720,7 @@
           <p:cNvPr id="13" name="icon">
             <a:extLst>
               <a:ext uri="{FF2B5EF4-FFF2-40B4-BE49-F238E27FC236}">
-                <a16:creationId xmlns:a16="http://schemas.microsoft.com/office/drawing/2014/main" id="{55AA77CA-E888-A7DA-295D-76741FD2AA90}"/>
+                <a16:creationId xmlns:a16="http://schemas.microsoft.com/office/drawing/2014/main" id="{C142DD4D-1C57-B871-6C1E-DBED6C1193FD}"/>
               </a:ext>
             </a:extLst>
           </p:cNvPr>
@@ -25740,7 +25756,7 @@
           <p:cNvPr id="15" name="icon">
             <a:extLst>
               <a:ext uri="{FF2B5EF4-FFF2-40B4-BE49-F238E27FC236}">
-                <a16:creationId xmlns:a16="http://schemas.microsoft.com/office/drawing/2014/main" id="{B115D2BA-2E5F-6152-7D21-39B8FE772714}"/>
+                <a16:creationId xmlns:a16="http://schemas.microsoft.com/office/drawing/2014/main" id="{59036254-3EF0-BA8B-CDCE-B4291EE4180A}"/>
               </a:ext>
             </a:extLst>
           </p:cNvPr>
@@ -25776,7 +25792,7 @@
           <p:cNvPr id="17" name="icon">
             <a:extLst>
               <a:ext uri="{FF2B5EF4-FFF2-40B4-BE49-F238E27FC236}">
-                <a16:creationId xmlns:a16="http://schemas.microsoft.com/office/drawing/2014/main" id="{4C6BDF48-C877-CF32-2A13-06ACC765E1E0}"/>
+                <a16:creationId xmlns:a16="http://schemas.microsoft.com/office/drawing/2014/main" id="{2AC3E651-92AF-1835-B55A-63D36A89CC1D}"/>
               </a:ext>
             </a:extLst>
           </p:cNvPr>
@@ -25812,7 +25828,7 @@
           <p:cNvPr id="19" name="icon">
             <a:extLst>
               <a:ext uri="{FF2B5EF4-FFF2-40B4-BE49-F238E27FC236}">
-                <a16:creationId xmlns:a16="http://schemas.microsoft.com/office/drawing/2014/main" id="{01052164-D775-351C-7FFC-040FBEA19DBB}"/>
+                <a16:creationId xmlns:a16="http://schemas.microsoft.com/office/drawing/2014/main" id="{6BB3065A-D6E0-04BE-A7B5-437218289D3F}"/>
               </a:ext>
             </a:extLst>
           </p:cNvPr>
@@ -25848,7 +25864,7 @@
           <p:cNvPr id="21" name="icon">
             <a:extLst>
               <a:ext uri="{FF2B5EF4-FFF2-40B4-BE49-F238E27FC236}">
-                <a16:creationId xmlns:a16="http://schemas.microsoft.com/office/drawing/2014/main" id="{8302F47F-89FF-AEFB-485D-6CFFC3386ABF}"/>
+                <a16:creationId xmlns:a16="http://schemas.microsoft.com/office/drawing/2014/main" id="{44F07D6A-FCBC-0077-4169-82C9F05B2C69}"/>
               </a:ext>
             </a:extLst>
           </p:cNvPr>
@@ -25884,7 +25900,7 @@
           <p:cNvPr id="23" name="icon">
             <a:extLst>
               <a:ext uri="{FF2B5EF4-FFF2-40B4-BE49-F238E27FC236}">
-                <a16:creationId xmlns:a16="http://schemas.microsoft.com/office/drawing/2014/main" id="{C9D08A88-8120-556D-E206-E1FA9C63B15F}"/>
+                <a16:creationId xmlns:a16="http://schemas.microsoft.com/office/drawing/2014/main" id="{EB052D95-29B8-9726-E05E-F09AB2B01F89}"/>
               </a:ext>
             </a:extLst>
           </p:cNvPr>
@@ -25920,7 +25936,7 @@
           <p:cNvPr id="25" name="icon">
             <a:extLst>
               <a:ext uri="{FF2B5EF4-FFF2-40B4-BE49-F238E27FC236}">
-                <a16:creationId xmlns:a16="http://schemas.microsoft.com/office/drawing/2014/main" id="{1477A7C7-1B93-530A-CDF1-8F7DD93819EB}"/>
+                <a16:creationId xmlns:a16="http://schemas.microsoft.com/office/drawing/2014/main" id="{52946799-B482-4831-6107-3574B3BAC217}"/>
               </a:ext>
             </a:extLst>
           </p:cNvPr>
@@ -25956,7 +25972,7 @@
           <p:cNvPr id="27" name="icon">
             <a:extLst>
               <a:ext uri="{FF2B5EF4-FFF2-40B4-BE49-F238E27FC236}">
-                <a16:creationId xmlns:a16="http://schemas.microsoft.com/office/drawing/2014/main" id="{A4A8976C-A066-D1FB-BCD7-2747AB75F5B8}"/>
+                <a16:creationId xmlns:a16="http://schemas.microsoft.com/office/drawing/2014/main" id="{2E52B3CB-13B4-56A1-FB3C-769AC8BC6161}"/>
               </a:ext>
             </a:extLst>
           </p:cNvPr>
@@ -25992,7 +26008,7 @@
           <p:cNvPr id="29" name="icon">
             <a:extLst>
               <a:ext uri="{FF2B5EF4-FFF2-40B4-BE49-F238E27FC236}">
-                <a16:creationId xmlns:a16="http://schemas.microsoft.com/office/drawing/2014/main" id="{480151E2-6DDE-3A1B-C670-F0440DD26C6C}"/>
+                <a16:creationId xmlns:a16="http://schemas.microsoft.com/office/drawing/2014/main" id="{85537767-F168-57DB-EEC0-83C8E594F4C3}"/>
               </a:ext>
             </a:extLst>
           </p:cNvPr>
@@ -26028,7 +26044,7 @@
           <p:cNvPr id="31" name="icon">
             <a:extLst>
               <a:ext uri="{FF2B5EF4-FFF2-40B4-BE49-F238E27FC236}">
-                <a16:creationId xmlns:a16="http://schemas.microsoft.com/office/drawing/2014/main" id="{BB7918E4-28D9-E1DC-8748-00E23ECE8D48}"/>
+                <a16:creationId xmlns:a16="http://schemas.microsoft.com/office/drawing/2014/main" id="{8BFDEA4A-AF24-4800-53F5-0323CEAB9D74}"/>
               </a:ext>
             </a:extLst>
           </p:cNvPr>
@@ -26064,7 +26080,7 @@
           <p:cNvPr id="33" name="icon">
             <a:extLst>
               <a:ext uri="{FF2B5EF4-FFF2-40B4-BE49-F238E27FC236}">
-                <a16:creationId xmlns:a16="http://schemas.microsoft.com/office/drawing/2014/main" id="{8DE4F2DC-AC46-51F8-3235-9EE2BEC139FB}"/>
+                <a16:creationId xmlns:a16="http://schemas.microsoft.com/office/drawing/2014/main" id="{281AB899-47BF-F230-3C82-1FDCCC0D707F}"/>
               </a:ext>
             </a:extLst>
           </p:cNvPr>
@@ -26100,7 +26116,7 @@
           <p:cNvPr id="35" name="icon">
             <a:extLst>
               <a:ext uri="{FF2B5EF4-FFF2-40B4-BE49-F238E27FC236}">
-                <a16:creationId xmlns:a16="http://schemas.microsoft.com/office/drawing/2014/main" id="{163B100B-B570-96A7-3372-556AE1B66A12}"/>
+                <a16:creationId xmlns:a16="http://schemas.microsoft.com/office/drawing/2014/main" id="{DC314057-733E-9CC3-F460-42848D46F0F3}"/>
               </a:ext>
             </a:extLst>
           </p:cNvPr>
@@ -26136,7 +26152,7 @@
           <p:cNvPr id="37" name="icon">
             <a:extLst>
               <a:ext uri="{FF2B5EF4-FFF2-40B4-BE49-F238E27FC236}">
-                <a16:creationId xmlns:a16="http://schemas.microsoft.com/office/drawing/2014/main" id="{2070C135-F9A1-D850-EFBD-4C4A6D6AC877}"/>
+                <a16:creationId xmlns:a16="http://schemas.microsoft.com/office/drawing/2014/main" id="{69A46BE4-D06F-0910-1355-CE3505B1DBAD}"/>
               </a:ext>
             </a:extLst>
           </p:cNvPr>
@@ -26172,7 +26188,7 @@
           <p:cNvPr id="39" name="icon">
             <a:extLst>
               <a:ext uri="{FF2B5EF4-FFF2-40B4-BE49-F238E27FC236}">
-                <a16:creationId xmlns:a16="http://schemas.microsoft.com/office/drawing/2014/main" id="{8FC7989C-7598-2C2E-4815-25780DF83E69}"/>
+                <a16:creationId xmlns:a16="http://schemas.microsoft.com/office/drawing/2014/main" id="{E7DF67A1-A013-EBE1-5008-F498DC807132}"/>
               </a:ext>
             </a:extLst>
           </p:cNvPr>
@@ -26208,7 +26224,7 @@
           <p:cNvPr id="41" name="icon">
             <a:extLst>
               <a:ext uri="{FF2B5EF4-FFF2-40B4-BE49-F238E27FC236}">
-                <a16:creationId xmlns:a16="http://schemas.microsoft.com/office/drawing/2014/main" id="{FD6CF39B-D0D8-A939-09A0-5E2F3960E6BE}"/>
+                <a16:creationId xmlns:a16="http://schemas.microsoft.com/office/drawing/2014/main" id="{C73ADA6E-C192-35D8-3342-EB8089A2502C}"/>
               </a:ext>
             </a:extLst>
           </p:cNvPr>
@@ -29938,7 +29954,7 @@
           <p:cNvPr id="3" name="icon">
             <a:extLst>
               <a:ext uri="{FF2B5EF4-FFF2-40B4-BE49-F238E27FC236}">
-                <a16:creationId xmlns:a16="http://schemas.microsoft.com/office/drawing/2014/main" id="{3E4F2CDD-CA0E-1716-CC6C-397B6317B5F7}"/>
+                <a16:creationId xmlns:a16="http://schemas.microsoft.com/office/drawing/2014/main" id="{C3142F2A-1511-FB20-8B08-C8EC7D9A3EE7}"/>
               </a:ext>
             </a:extLst>
           </p:cNvPr>
@@ -29974,7 +29990,7 @@
           <p:cNvPr id="5" name="icon">
             <a:extLst>
               <a:ext uri="{FF2B5EF4-FFF2-40B4-BE49-F238E27FC236}">
-                <a16:creationId xmlns:a16="http://schemas.microsoft.com/office/drawing/2014/main" id="{C80B4C7C-1BF0-71A5-19AF-9A3923792AB5}"/>
+                <a16:creationId xmlns:a16="http://schemas.microsoft.com/office/drawing/2014/main" id="{DAE5FB8C-66C1-8380-291B-870A9E5C4C05}"/>
               </a:ext>
             </a:extLst>
           </p:cNvPr>
@@ -30010,7 +30026,7 @@
           <p:cNvPr id="7" name="icon">
             <a:extLst>
               <a:ext uri="{FF2B5EF4-FFF2-40B4-BE49-F238E27FC236}">
-                <a16:creationId xmlns:a16="http://schemas.microsoft.com/office/drawing/2014/main" id="{7B4A6591-68C2-6C61-3AFF-531D11A2BB3E}"/>
+                <a16:creationId xmlns:a16="http://schemas.microsoft.com/office/drawing/2014/main" id="{2BB3AE7F-4111-D110-0DA5-08A1FC653994}"/>
               </a:ext>
             </a:extLst>
           </p:cNvPr>
@@ -30046,7 +30062,7 @@
           <p:cNvPr id="9" name="icon">
             <a:extLst>
               <a:ext uri="{FF2B5EF4-FFF2-40B4-BE49-F238E27FC236}">
-                <a16:creationId xmlns:a16="http://schemas.microsoft.com/office/drawing/2014/main" id="{EDDF799B-A66E-3DCB-EB6E-3855B3E59895}"/>
+                <a16:creationId xmlns:a16="http://schemas.microsoft.com/office/drawing/2014/main" id="{75E0EFA4-E4DC-7C4E-9902-3F8E02F911D2}"/>
               </a:ext>
             </a:extLst>
           </p:cNvPr>
@@ -30082,7 +30098,7 @@
           <p:cNvPr id="11" name="icon">
             <a:extLst>
               <a:ext uri="{FF2B5EF4-FFF2-40B4-BE49-F238E27FC236}">
-                <a16:creationId xmlns:a16="http://schemas.microsoft.com/office/drawing/2014/main" id="{A00CD71B-C7CC-80F7-2697-51EDE35DD613}"/>
+                <a16:creationId xmlns:a16="http://schemas.microsoft.com/office/drawing/2014/main" id="{FAB829A3-CF31-978D-A74A-F79CF309F5FB}"/>
               </a:ext>
             </a:extLst>
           </p:cNvPr>
@@ -30118,7 +30134,7 @@
           <p:cNvPr id="13" name="icon">
             <a:extLst>
               <a:ext uri="{FF2B5EF4-FFF2-40B4-BE49-F238E27FC236}">
-                <a16:creationId xmlns:a16="http://schemas.microsoft.com/office/drawing/2014/main" id="{903110DB-3AA7-6C07-A3B8-8FB1C784C92D}"/>
+                <a16:creationId xmlns:a16="http://schemas.microsoft.com/office/drawing/2014/main" id="{B539E6CC-B770-E58E-3C5B-BE70C38FA67D}"/>
               </a:ext>
             </a:extLst>
           </p:cNvPr>
@@ -30154,7 +30170,7 @@
           <p:cNvPr id="15" name="icon">
             <a:extLst>
               <a:ext uri="{FF2B5EF4-FFF2-40B4-BE49-F238E27FC236}">
-                <a16:creationId xmlns:a16="http://schemas.microsoft.com/office/drawing/2014/main" id="{B75D180F-6FDE-345D-40BE-029B1E4D35E2}"/>
+                <a16:creationId xmlns:a16="http://schemas.microsoft.com/office/drawing/2014/main" id="{D07F3C16-8B9E-646E-050A-DA19243C049D}"/>
               </a:ext>
             </a:extLst>
           </p:cNvPr>
@@ -30190,7 +30206,7 @@
           <p:cNvPr id="17" name="icon">
             <a:extLst>
               <a:ext uri="{FF2B5EF4-FFF2-40B4-BE49-F238E27FC236}">
-                <a16:creationId xmlns:a16="http://schemas.microsoft.com/office/drawing/2014/main" id="{151BE6FF-792A-FC8E-EE63-DD21FA9D14A7}"/>
+                <a16:creationId xmlns:a16="http://schemas.microsoft.com/office/drawing/2014/main" id="{3055FFF4-8621-A599-98B3-017511C3D68B}"/>
               </a:ext>
             </a:extLst>
           </p:cNvPr>
@@ -30226,7 +30242,7 @@
           <p:cNvPr id="19" name="icon">
             <a:extLst>
               <a:ext uri="{FF2B5EF4-FFF2-40B4-BE49-F238E27FC236}">
-                <a16:creationId xmlns:a16="http://schemas.microsoft.com/office/drawing/2014/main" id="{FB0124AF-BEFA-2679-8B21-D4F82AB4A2E6}"/>
+                <a16:creationId xmlns:a16="http://schemas.microsoft.com/office/drawing/2014/main" id="{882CE35B-0EB5-3842-9E1B-1956E6DEA2A3}"/>
               </a:ext>
             </a:extLst>
           </p:cNvPr>
@@ -30262,7 +30278,7 @@
           <p:cNvPr id="21" name="icon">
             <a:extLst>
               <a:ext uri="{FF2B5EF4-FFF2-40B4-BE49-F238E27FC236}">
-                <a16:creationId xmlns:a16="http://schemas.microsoft.com/office/drawing/2014/main" id="{F21EBC7C-7016-3EEE-0B5D-93DA043E1F4E}"/>
+                <a16:creationId xmlns:a16="http://schemas.microsoft.com/office/drawing/2014/main" id="{9B5A164D-EF54-CA26-71BA-91240F935B52}"/>
               </a:ext>
             </a:extLst>
           </p:cNvPr>
@@ -30298,7 +30314,7 @@
           <p:cNvPr id="23" name="icon">
             <a:extLst>
               <a:ext uri="{FF2B5EF4-FFF2-40B4-BE49-F238E27FC236}">
-                <a16:creationId xmlns:a16="http://schemas.microsoft.com/office/drawing/2014/main" id="{2F6DB620-033F-4741-5416-F6E1B502A213}"/>
+                <a16:creationId xmlns:a16="http://schemas.microsoft.com/office/drawing/2014/main" id="{5D2DCB47-6C1B-AF56-4803-B7592BD0E847}"/>
               </a:ext>
             </a:extLst>
           </p:cNvPr>
@@ -30334,7 +30350,7 @@
           <p:cNvPr id="25" name="icon">
             <a:extLst>
               <a:ext uri="{FF2B5EF4-FFF2-40B4-BE49-F238E27FC236}">
-                <a16:creationId xmlns:a16="http://schemas.microsoft.com/office/drawing/2014/main" id="{7BCBE110-87D7-A4DB-4BE0-7E331C554E46}"/>
+                <a16:creationId xmlns:a16="http://schemas.microsoft.com/office/drawing/2014/main" id="{F8776D0B-274D-8825-2C4A-B0A28B260BBA}"/>
               </a:ext>
             </a:extLst>
           </p:cNvPr>
@@ -30370,7 +30386,7 @@
           <p:cNvPr id="27" name="icon">
             <a:extLst>
               <a:ext uri="{FF2B5EF4-FFF2-40B4-BE49-F238E27FC236}">
-                <a16:creationId xmlns:a16="http://schemas.microsoft.com/office/drawing/2014/main" id="{7D323BCB-F9EE-DD5D-2F1B-6B8416BB91F6}"/>
+                <a16:creationId xmlns:a16="http://schemas.microsoft.com/office/drawing/2014/main" id="{A8F26973-E351-8C44-2E7B-A31290500C1B}"/>
               </a:ext>
             </a:extLst>
           </p:cNvPr>
@@ -30406,7 +30422,7 @@
           <p:cNvPr id="29" name="icon">
             <a:extLst>
               <a:ext uri="{FF2B5EF4-FFF2-40B4-BE49-F238E27FC236}">
-                <a16:creationId xmlns:a16="http://schemas.microsoft.com/office/drawing/2014/main" id="{AD49AA69-13BE-FEA0-963F-CD4342B5C0CF}"/>
+                <a16:creationId xmlns:a16="http://schemas.microsoft.com/office/drawing/2014/main" id="{B9C3500E-4246-9EBA-E40C-77220E84879B}"/>
               </a:ext>
             </a:extLst>
           </p:cNvPr>
@@ -30442,7 +30458,7 @@
           <p:cNvPr id="31" name="icon">
             <a:extLst>
               <a:ext uri="{FF2B5EF4-FFF2-40B4-BE49-F238E27FC236}">
-                <a16:creationId xmlns:a16="http://schemas.microsoft.com/office/drawing/2014/main" id="{0A7197F5-621D-CFF2-A6AB-0E8EA71811EA}"/>
+                <a16:creationId xmlns:a16="http://schemas.microsoft.com/office/drawing/2014/main" id="{90D60023-4FF9-9E91-1CCD-58FCBDC55EEB}"/>
               </a:ext>
             </a:extLst>
           </p:cNvPr>
@@ -30478,7 +30494,7 @@
           <p:cNvPr id="33" name="icon">
             <a:extLst>
               <a:ext uri="{FF2B5EF4-FFF2-40B4-BE49-F238E27FC236}">
-                <a16:creationId xmlns:a16="http://schemas.microsoft.com/office/drawing/2014/main" id="{96DD29A1-1017-360D-B8B9-998B412688EC}"/>
+                <a16:creationId xmlns:a16="http://schemas.microsoft.com/office/drawing/2014/main" id="{9AAA8C94-9A9C-8242-45A0-7EDEFEFF5541}"/>
               </a:ext>
             </a:extLst>
           </p:cNvPr>
@@ -30514,7 +30530,7 @@
           <p:cNvPr id="35" name="icon">
             <a:extLst>
               <a:ext uri="{FF2B5EF4-FFF2-40B4-BE49-F238E27FC236}">
-                <a16:creationId xmlns:a16="http://schemas.microsoft.com/office/drawing/2014/main" id="{F9D9B2CA-260A-0ED6-1452-000985D50B60}"/>
+                <a16:creationId xmlns:a16="http://schemas.microsoft.com/office/drawing/2014/main" id="{9219C42B-2B0B-CE41-7DC9-818213E9979A}"/>
               </a:ext>
             </a:extLst>
           </p:cNvPr>
@@ -30550,7 +30566,7 @@
           <p:cNvPr id="37" name="icon">
             <a:extLst>
               <a:ext uri="{FF2B5EF4-FFF2-40B4-BE49-F238E27FC236}">
-                <a16:creationId xmlns:a16="http://schemas.microsoft.com/office/drawing/2014/main" id="{2013B34A-DA53-BCA5-5928-69F836439F21}"/>
+                <a16:creationId xmlns:a16="http://schemas.microsoft.com/office/drawing/2014/main" id="{CEF8B0D1-CB06-F65F-2D34-C42EB5E5AF29}"/>
               </a:ext>
             </a:extLst>
           </p:cNvPr>
@@ -32327,7 +32343,7 @@
           <p:cNvPr id="3" name="icon">
             <a:extLst>
               <a:ext uri="{FF2B5EF4-FFF2-40B4-BE49-F238E27FC236}">
-                <a16:creationId xmlns:a16="http://schemas.microsoft.com/office/drawing/2014/main" id="{105180D1-1CC4-129D-3195-2A17C9B65F2B}"/>
+                <a16:creationId xmlns:a16="http://schemas.microsoft.com/office/drawing/2014/main" id="{F1D7A1DC-82E5-C1A8-0920-DFC58E58EC7D}"/>
               </a:ext>
             </a:extLst>
           </p:cNvPr>
@@ -32363,7 +32379,7 @@
           <p:cNvPr id="5" name="icon">
             <a:extLst>
               <a:ext uri="{FF2B5EF4-FFF2-40B4-BE49-F238E27FC236}">
-                <a16:creationId xmlns:a16="http://schemas.microsoft.com/office/drawing/2014/main" id="{92760B94-9DFB-DF61-5CA4-EF832B49460F}"/>
+                <a16:creationId xmlns:a16="http://schemas.microsoft.com/office/drawing/2014/main" id="{FFCB7DAA-E777-531F-6853-05108A5CF6DD}"/>
               </a:ext>
             </a:extLst>
           </p:cNvPr>
@@ -32399,7 +32415,7 @@
           <p:cNvPr id="7" name="icon">
             <a:extLst>
               <a:ext uri="{FF2B5EF4-FFF2-40B4-BE49-F238E27FC236}">
-                <a16:creationId xmlns:a16="http://schemas.microsoft.com/office/drawing/2014/main" id="{55CCD29B-DCD3-63B9-2C91-D619540E5BE2}"/>
+                <a16:creationId xmlns:a16="http://schemas.microsoft.com/office/drawing/2014/main" id="{1B2AF2B5-F3F0-8DFE-B39E-A920617FE0A6}"/>
               </a:ext>
             </a:extLst>
           </p:cNvPr>
@@ -32435,7 +32451,7 @@
           <p:cNvPr id="9" name="icon">
             <a:extLst>
               <a:ext uri="{FF2B5EF4-FFF2-40B4-BE49-F238E27FC236}">
-                <a16:creationId xmlns:a16="http://schemas.microsoft.com/office/drawing/2014/main" id="{01E1CDC3-8624-7D12-39F4-03C8A50194FE}"/>
+                <a16:creationId xmlns:a16="http://schemas.microsoft.com/office/drawing/2014/main" id="{754F230B-DF04-CF5C-9246-1631B7AB1928}"/>
               </a:ext>
             </a:extLst>
           </p:cNvPr>
@@ -34820,7 +34836,7 @@
           <p:cNvPr id="3" name="icon">
             <a:extLst>
               <a:ext uri="{FF2B5EF4-FFF2-40B4-BE49-F238E27FC236}">
-                <a16:creationId xmlns:a16="http://schemas.microsoft.com/office/drawing/2014/main" id="{AB7E8110-2823-65A0-83AF-36F8A5543675}"/>
+                <a16:creationId xmlns:a16="http://schemas.microsoft.com/office/drawing/2014/main" id="{4A8E1117-BA08-3090-F8AE-342EE88D446B}"/>
               </a:ext>
             </a:extLst>
           </p:cNvPr>
@@ -34856,7 +34872,7 @@
           <p:cNvPr id="5" name="icon">
             <a:extLst>
               <a:ext uri="{FF2B5EF4-FFF2-40B4-BE49-F238E27FC236}">
-                <a16:creationId xmlns:a16="http://schemas.microsoft.com/office/drawing/2014/main" id="{948A5777-2736-5663-5CEF-AB3DFCE85B54}"/>
+                <a16:creationId xmlns:a16="http://schemas.microsoft.com/office/drawing/2014/main" id="{11D21F90-64DC-DA85-1FF1-767F356FECC1}"/>
               </a:ext>
             </a:extLst>
           </p:cNvPr>
@@ -34892,7 +34908,7 @@
           <p:cNvPr id="7" name="icon">
             <a:extLst>
               <a:ext uri="{FF2B5EF4-FFF2-40B4-BE49-F238E27FC236}">
-                <a16:creationId xmlns:a16="http://schemas.microsoft.com/office/drawing/2014/main" id="{02D8E209-F915-55DE-5AD6-5CAB1E309983}"/>
+                <a16:creationId xmlns:a16="http://schemas.microsoft.com/office/drawing/2014/main" id="{CBCBFBC4-6F1D-3F26-98C6-840020C03F60}"/>
               </a:ext>
             </a:extLst>
           </p:cNvPr>
@@ -34928,7 +34944,7 @@
           <p:cNvPr id="9" name="icon">
             <a:extLst>
               <a:ext uri="{FF2B5EF4-FFF2-40B4-BE49-F238E27FC236}">
-                <a16:creationId xmlns:a16="http://schemas.microsoft.com/office/drawing/2014/main" id="{D5BE2410-B5D2-237C-FFCB-FB5AB7A58DD2}"/>
+                <a16:creationId xmlns:a16="http://schemas.microsoft.com/office/drawing/2014/main" id="{FB3C55D4-5A62-9308-A494-62A0343AD9D4}"/>
               </a:ext>
             </a:extLst>
           </p:cNvPr>
@@ -34964,7 +34980,7 @@
           <p:cNvPr id="11" name="icon">
             <a:extLst>
               <a:ext uri="{FF2B5EF4-FFF2-40B4-BE49-F238E27FC236}">
-                <a16:creationId xmlns:a16="http://schemas.microsoft.com/office/drawing/2014/main" id="{16FB6DFC-31CE-7FD6-2F21-CB9839A3A3DB}"/>
+                <a16:creationId xmlns:a16="http://schemas.microsoft.com/office/drawing/2014/main" id="{E05F72F3-00CF-A239-7EF7-A82790F1AD94}"/>
               </a:ext>
             </a:extLst>
           </p:cNvPr>
@@ -35000,7 +35016,7 @@
           <p:cNvPr id="13" name="icon">
             <a:extLst>
               <a:ext uri="{FF2B5EF4-FFF2-40B4-BE49-F238E27FC236}">
-                <a16:creationId xmlns:a16="http://schemas.microsoft.com/office/drawing/2014/main" id="{2A842747-C740-C6CA-7414-CD9B6382218D}"/>
+                <a16:creationId xmlns:a16="http://schemas.microsoft.com/office/drawing/2014/main" id="{E20F3A27-0CC2-2F8B-81BF-9008F5B35572}"/>
               </a:ext>
             </a:extLst>
           </p:cNvPr>
@@ -35036,7 +35052,7 @@
           <p:cNvPr id="15" name="icon">
             <a:extLst>
               <a:ext uri="{FF2B5EF4-FFF2-40B4-BE49-F238E27FC236}">
-                <a16:creationId xmlns:a16="http://schemas.microsoft.com/office/drawing/2014/main" id="{0ED39319-5A51-7062-E21D-9AA9DA6D4319}"/>
+                <a16:creationId xmlns:a16="http://schemas.microsoft.com/office/drawing/2014/main" id="{86B16C5C-13C9-D663-B7DD-34E987541A96}"/>
               </a:ext>
             </a:extLst>
           </p:cNvPr>
@@ -35072,7 +35088,7 @@
           <p:cNvPr id="17" name="icon">
             <a:extLst>
               <a:ext uri="{FF2B5EF4-FFF2-40B4-BE49-F238E27FC236}">
-                <a16:creationId xmlns:a16="http://schemas.microsoft.com/office/drawing/2014/main" id="{0C08F061-06AA-BD2A-10D4-2B5F3C63A696}"/>
+                <a16:creationId xmlns:a16="http://schemas.microsoft.com/office/drawing/2014/main" id="{737FF397-B9B4-9859-0CFC-92F78FC0CA10}"/>
               </a:ext>
             </a:extLst>
           </p:cNvPr>
@@ -35108,7 +35124,7 @@
           <p:cNvPr id="19" name="icon">
             <a:extLst>
               <a:ext uri="{FF2B5EF4-FFF2-40B4-BE49-F238E27FC236}">
-                <a16:creationId xmlns:a16="http://schemas.microsoft.com/office/drawing/2014/main" id="{EBC8E17C-824D-7033-9A87-A6D21B7C069D}"/>
+                <a16:creationId xmlns:a16="http://schemas.microsoft.com/office/drawing/2014/main" id="{EE335B70-256C-3B83-CF8D-2DDE9770A7BB}"/>
               </a:ext>
             </a:extLst>
           </p:cNvPr>
@@ -35144,7 +35160,7 @@
           <p:cNvPr id="21" name="icon">
             <a:extLst>
               <a:ext uri="{FF2B5EF4-FFF2-40B4-BE49-F238E27FC236}">
-                <a16:creationId xmlns:a16="http://schemas.microsoft.com/office/drawing/2014/main" id="{90EF38E2-F35C-767D-AD55-7134F9392FCD}"/>
+                <a16:creationId xmlns:a16="http://schemas.microsoft.com/office/drawing/2014/main" id="{378A263E-17BA-92C0-50A0-64E80FADC396}"/>
               </a:ext>
             </a:extLst>
           </p:cNvPr>
@@ -35180,7 +35196,7 @@
           <p:cNvPr id="23" name="icon">
             <a:extLst>
               <a:ext uri="{FF2B5EF4-FFF2-40B4-BE49-F238E27FC236}">
-                <a16:creationId xmlns:a16="http://schemas.microsoft.com/office/drawing/2014/main" id="{E9C4292A-0BDE-FAD7-84C1-E45AB7EB1B6C}"/>
+                <a16:creationId xmlns:a16="http://schemas.microsoft.com/office/drawing/2014/main" id="{7494D3A2-87DE-F7C0-9EDF-9EA520A8DFEE}"/>
               </a:ext>
             </a:extLst>
           </p:cNvPr>
@@ -35216,7 +35232,7 @@
           <p:cNvPr id="25" name="icon">
             <a:extLst>
               <a:ext uri="{FF2B5EF4-FFF2-40B4-BE49-F238E27FC236}">
-                <a16:creationId xmlns:a16="http://schemas.microsoft.com/office/drawing/2014/main" id="{B2B6B2FE-BC8A-09E7-630E-8565162A0358}"/>
+                <a16:creationId xmlns:a16="http://schemas.microsoft.com/office/drawing/2014/main" id="{17D65912-689E-023F-A196-30816BBB9937}"/>
               </a:ext>
             </a:extLst>
           </p:cNvPr>
@@ -35252,7 +35268,7 @@
           <p:cNvPr id="27" name="icon">
             <a:extLst>
               <a:ext uri="{FF2B5EF4-FFF2-40B4-BE49-F238E27FC236}">
-                <a16:creationId xmlns:a16="http://schemas.microsoft.com/office/drawing/2014/main" id="{80886F7C-7FF1-C9ED-754A-15F765EAE15F}"/>
+                <a16:creationId xmlns:a16="http://schemas.microsoft.com/office/drawing/2014/main" id="{A1E94B81-1DA6-DBA0-F3DB-01D064E5FABE}"/>
               </a:ext>
             </a:extLst>
           </p:cNvPr>
@@ -35288,7 +35304,7 @@
           <p:cNvPr id="29" name="icon">
             <a:extLst>
               <a:ext uri="{FF2B5EF4-FFF2-40B4-BE49-F238E27FC236}">
-                <a16:creationId xmlns:a16="http://schemas.microsoft.com/office/drawing/2014/main" id="{2495920A-4F40-229E-347B-250F794F9871}"/>
+                <a16:creationId xmlns:a16="http://schemas.microsoft.com/office/drawing/2014/main" id="{AF858C00-FF54-06B0-7FEB-50DA4E39EC7D}"/>
               </a:ext>
             </a:extLst>
           </p:cNvPr>
@@ -35324,7 +35340,7 @@
           <p:cNvPr id="31" name="icon">
             <a:extLst>
               <a:ext uri="{FF2B5EF4-FFF2-40B4-BE49-F238E27FC236}">
-                <a16:creationId xmlns:a16="http://schemas.microsoft.com/office/drawing/2014/main" id="{5BF4480A-4E5D-F1D9-94F0-FF511AD83B80}"/>
+                <a16:creationId xmlns:a16="http://schemas.microsoft.com/office/drawing/2014/main" id="{BE85321F-2195-9282-FE02-7D243DB5F900}"/>
               </a:ext>
             </a:extLst>
           </p:cNvPr>
@@ -35360,7 +35376,7 @@
           <p:cNvPr id="33" name="icon">
             <a:extLst>
               <a:ext uri="{FF2B5EF4-FFF2-40B4-BE49-F238E27FC236}">
-                <a16:creationId xmlns:a16="http://schemas.microsoft.com/office/drawing/2014/main" id="{2F4BF468-A07D-001C-2F85-40BEBD7E3213}"/>
+                <a16:creationId xmlns:a16="http://schemas.microsoft.com/office/drawing/2014/main" id="{AACF7240-8E68-F2A6-4705-CDC60C5A8908}"/>
               </a:ext>
             </a:extLst>
           </p:cNvPr>
@@ -35396,7 +35412,7 @@
           <p:cNvPr id="35" name="icon">
             <a:extLst>
               <a:ext uri="{FF2B5EF4-FFF2-40B4-BE49-F238E27FC236}">
-                <a16:creationId xmlns:a16="http://schemas.microsoft.com/office/drawing/2014/main" id="{0491A845-8532-36AF-CFAC-E5B52290F07B}"/>
+                <a16:creationId xmlns:a16="http://schemas.microsoft.com/office/drawing/2014/main" id="{1A9C2526-0ED5-8296-7399-96AB086B53BF}"/>
               </a:ext>
             </a:extLst>
           </p:cNvPr>
@@ -35432,7 +35448,7 @@
           <p:cNvPr id="37" name="icon">
             <a:extLst>
               <a:ext uri="{FF2B5EF4-FFF2-40B4-BE49-F238E27FC236}">
-                <a16:creationId xmlns:a16="http://schemas.microsoft.com/office/drawing/2014/main" id="{2352CFF3-1B4B-5A28-F4FD-62746BD35A28}"/>
+                <a16:creationId xmlns:a16="http://schemas.microsoft.com/office/drawing/2014/main" id="{195C7F63-7B74-C3B2-7957-31D295E360A3}"/>
               </a:ext>
             </a:extLst>
           </p:cNvPr>
@@ -37621,7 +37637,7 @@
           <p:cNvPr id="3" name="icon">
             <a:extLst>
               <a:ext uri="{FF2B5EF4-FFF2-40B4-BE49-F238E27FC236}">
-                <a16:creationId xmlns:a16="http://schemas.microsoft.com/office/drawing/2014/main" id="{61205233-B930-E69F-6F11-B2CB35280A9B}"/>
+                <a16:creationId xmlns:a16="http://schemas.microsoft.com/office/drawing/2014/main" id="{43A9E920-7758-12CB-0466-89C6D499F09E}"/>
               </a:ext>
             </a:extLst>
           </p:cNvPr>
@@ -37657,7 +37673,7 @@
           <p:cNvPr id="5" name="icon">
             <a:extLst>
               <a:ext uri="{FF2B5EF4-FFF2-40B4-BE49-F238E27FC236}">
-                <a16:creationId xmlns:a16="http://schemas.microsoft.com/office/drawing/2014/main" id="{978A9BCA-3748-12F2-97A2-F0DD8D5748DC}"/>
+                <a16:creationId xmlns:a16="http://schemas.microsoft.com/office/drawing/2014/main" id="{248268E3-94F8-83FD-E29A-E77AE5540062}"/>
               </a:ext>
             </a:extLst>
           </p:cNvPr>
@@ -37693,7 +37709,7 @@
           <p:cNvPr id="7" name="icon">
             <a:extLst>
               <a:ext uri="{FF2B5EF4-FFF2-40B4-BE49-F238E27FC236}">
-                <a16:creationId xmlns:a16="http://schemas.microsoft.com/office/drawing/2014/main" id="{A484F624-35C8-2F9B-C656-565029CCD3A2}"/>
+                <a16:creationId xmlns:a16="http://schemas.microsoft.com/office/drawing/2014/main" id="{05B66A59-ED1A-86D3-061F-BB233B8A9ECF}"/>
               </a:ext>
             </a:extLst>
           </p:cNvPr>
@@ -39612,7 +39628,7 @@
           <p:cNvPr id="3" name="icon">
             <a:extLst>
               <a:ext uri="{FF2B5EF4-FFF2-40B4-BE49-F238E27FC236}">
-                <a16:creationId xmlns:a16="http://schemas.microsoft.com/office/drawing/2014/main" id="{566CE7DE-D2C5-4D7D-F820-D90B6996E57D}"/>
+                <a16:creationId xmlns:a16="http://schemas.microsoft.com/office/drawing/2014/main" id="{FF4DB0C2-61B3-6E88-B37D-9A51263710EB}"/>
               </a:ext>
             </a:extLst>
           </p:cNvPr>
@@ -39648,7 +39664,7 @@
           <p:cNvPr id="5" name="icon">
             <a:extLst>
               <a:ext uri="{FF2B5EF4-FFF2-40B4-BE49-F238E27FC236}">
-                <a16:creationId xmlns:a16="http://schemas.microsoft.com/office/drawing/2014/main" id="{F8D6A096-C6E7-4463-E5D3-FFDDE18262EF}"/>
+                <a16:creationId xmlns:a16="http://schemas.microsoft.com/office/drawing/2014/main" id="{0464105D-E05B-CE57-FD5C-5E8EF91C735B}"/>
               </a:ext>
             </a:extLst>
           </p:cNvPr>
@@ -39684,7 +39700,7 @@
           <p:cNvPr id="7" name="icon">
             <a:extLst>
               <a:ext uri="{FF2B5EF4-FFF2-40B4-BE49-F238E27FC236}">
-                <a16:creationId xmlns:a16="http://schemas.microsoft.com/office/drawing/2014/main" id="{3AC45067-0208-A0F7-656A-022615BEB96B}"/>
+                <a16:creationId xmlns:a16="http://schemas.microsoft.com/office/drawing/2014/main" id="{6561618C-7F34-C63A-85D3-E2EE1085F504}"/>
               </a:ext>
             </a:extLst>
           </p:cNvPr>
@@ -39720,7 +39736,7 @@
           <p:cNvPr id="9" name="icon">
             <a:extLst>
               <a:ext uri="{FF2B5EF4-FFF2-40B4-BE49-F238E27FC236}">
-                <a16:creationId xmlns:a16="http://schemas.microsoft.com/office/drawing/2014/main" id="{C5AB2876-FD24-965A-4994-F452FB0A10D3}"/>
+                <a16:creationId xmlns:a16="http://schemas.microsoft.com/office/drawing/2014/main" id="{42938A7A-E27A-DBDB-B4D1-F0B819BD77E6}"/>
               </a:ext>
             </a:extLst>
           </p:cNvPr>
@@ -39756,7 +39772,7 @@
           <p:cNvPr id="11" name="icon">
             <a:extLst>
               <a:ext uri="{FF2B5EF4-FFF2-40B4-BE49-F238E27FC236}">
-                <a16:creationId xmlns:a16="http://schemas.microsoft.com/office/drawing/2014/main" id="{6DBA30CE-5B85-0571-26FA-2AD2C63449AF}"/>
+                <a16:creationId xmlns:a16="http://schemas.microsoft.com/office/drawing/2014/main" id="{B69B0165-B5A1-660D-F8E1-D9DC185A14B8}"/>
               </a:ext>
             </a:extLst>
           </p:cNvPr>
@@ -39792,7 +39808,7 @@
           <p:cNvPr id="13" name="icon">
             <a:extLst>
               <a:ext uri="{FF2B5EF4-FFF2-40B4-BE49-F238E27FC236}">
-                <a16:creationId xmlns:a16="http://schemas.microsoft.com/office/drawing/2014/main" id="{9A29BEE6-A103-A425-EE40-785ED1BB5DBB}"/>
+                <a16:creationId xmlns:a16="http://schemas.microsoft.com/office/drawing/2014/main" id="{CAC4D2E5-9C7C-6104-F528-D820544B88D9}"/>
               </a:ext>
             </a:extLst>
           </p:cNvPr>
@@ -39828,7 +39844,7 @@
           <p:cNvPr id="15" name="icon">
             <a:extLst>
               <a:ext uri="{FF2B5EF4-FFF2-40B4-BE49-F238E27FC236}">
-                <a16:creationId xmlns:a16="http://schemas.microsoft.com/office/drawing/2014/main" id="{BD9E02AF-3E4A-21C8-55A1-AB6F90BEC127}"/>
+                <a16:creationId xmlns:a16="http://schemas.microsoft.com/office/drawing/2014/main" id="{10EB5485-1D09-E37C-1E1D-46FB0C7CDE2A}"/>
               </a:ext>
             </a:extLst>
           </p:cNvPr>
@@ -39864,7 +39880,7 @@
           <p:cNvPr id="17" name="icon">
             <a:extLst>
               <a:ext uri="{FF2B5EF4-FFF2-40B4-BE49-F238E27FC236}">
-                <a16:creationId xmlns:a16="http://schemas.microsoft.com/office/drawing/2014/main" id="{FF2EBEA7-A859-2839-A551-25F93B834732}"/>
+                <a16:creationId xmlns:a16="http://schemas.microsoft.com/office/drawing/2014/main" id="{A095B85F-FF55-19F5-576C-A5202C200FC7}"/>
               </a:ext>
             </a:extLst>
           </p:cNvPr>
@@ -39900,7 +39916,7 @@
           <p:cNvPr id="19" name="icon">
             <a:extLst>
               <a:ext uri="{FF2B5EF4-FFF2-40B4-BE49-F238E27FC236}">
-                <a16:creationId xmlns:a16="http://schemas.microsoft.com/office/drawing/2014/main" id="{DA64C7AE-7C35-444D-1A16-099D5169BAC2}"/>
+                <a16:creationId xmlns:a16="http://schemas.microsoft.com/office/drawing/2014/main" id="{8CBE65C5-21AC-9138-21B8-D9443615CF26}"/>
               </a:ext>
             </a:extLst>
           </p:cNvPr>
@@ -39936,7 +39952,7 @@
           <p:cNvPr id="21" name="icon">
             <a:extLst>
               <a:ext uri="{FF2B5EF4-FFF2-40B4-BE49-F238E27FC236}">
-                <a16:creationId xmlns:a16="http://schemas.microsoft.com/office/drawing/2014/main" id="{4163B58C-F529-C48F-010D-50701D59ADF6}"/>
+                <a16:creationId xmlns:a16="http://schemas.microsoft.com/office/drawing/2014/main" id="{E4E7A307-531B-DD81-A6C2-4A0656667B46}"/>
               </a:ext>
             </a:extLst>
           </p:cNvPr>
@@ -39972,7 +39988,7 @@
           <p:cNvPr id="23" name="icon">
             <a:extLst>
               <a:ext uri="{FF2B5EF4-FFF2-40B4-BE49-F238E27FC236}">
-                <a16:creationId xmlns:a16="http://schemas.microsoft.com/office/drawing/2014/main" id="{FBB6F45B-0171-2D92-1065-91E23376E400}"/>
+                <a16:creationId xmlns:a16="http://schemas.microsoft.com/office/drawing/2014/main" id="{CA12A16F-FEE8-626B-B436-8DCE6A398D57}"/>
               </a:ext>
             </a:extLst>
           </p:cNvPr>
@@ -40008,7 +40024,7 @@
           <p:cNvPr id="25" name="icon">
             <a:extLst>
               <a:ext uri="{FF2B5EF4-FFF2-40B4-BE49-F238E27FC236}">
-                <a16:creationId xmlns:a16="http://schemas.microsoft.com/office/drawing/2014/main" id="{015055C6-EB74-3FED-CBAB-715730BE8704}"/>
+                <a16:creationId xmlns:a16="http://schemas.microsoft.com/office/drawing/2014/main" id="{3E8E151B-5A6F-8244-1AF5-CFEF951D609A}"/>
               </a:ext>
             </a:extLst>
           </p:cNvPr>
@@ -40044,7 +40060,7 @@
           <p:cNvPr id="27" name="icon">
             <a:extLst>
               <a:ext uri="{FF2B5EF4-FFF2-40B4-BE49-F238E27FC236}">
-                <a16:creationId xmlns:a16="http://schemas.microsoft.com/office/drawing/2014/main" id="{9FC4BDD8-FE47-8609-0C36-8E64AD9C968C}"/>
+                <a16:creationId xmlns:a16="http://schemas.microsoft.com/office/drawing/2014/main" id="{4506AAE8-F852-DAF2-9578-6D808322D2CB}"/>
               </a:ext>
             </a:extLst>
           </p:cNvPr>
@@ -40080,7 +40096,7 @@
           <p:cNvPr id="29" name="icon">
             <a:extLst>
               <a:ext uri="{FF2B5EF4-FFF2-40B4-BE49-F238E27FC236}">
-                <a16:creationId xmlns:a16="http://schemas.microsoft.com/office/drawing/2014/main" id="{B45683B7-C1FA-EDC3-7419-9CA8A315DDEB}"/>
+                <a16:creationId xmlns:a16="http://schemas.microsoft.com/office/drawing/2014/main" id="{CCDB0AEA-689E-9FC1-8ECD-1A81870BCF8D}"/>
               </a:ext>
             </a:extLst>
           </p:cNvPr>
@@ -40116,7 +40132,7 @@
           <p:cNvPr id="31" name="icon">
             <a:extLst>
               <a:ext uri="{FF2B5EF4-FFF2-40B4-BE49-F238E27FC236}">
-                <a16:creationId xmlns:a16="http://schemas.microsoft.com/office/drawing/2014/main" id="{6D193CD4-A892-1DB8-E9FD-6CDA99260693}"/>
+                <a16:creationId xmlns:a16="http://schemas.microsoft.com/office/drawing/2014/main" id="{588E2553-5DF3-E51A-027E-F700B95C486A}"/>
               </a:ext>
             </a:extLst>
           </p:cNvPr>
@@ -40152,7 +40168,7 @@
           <p:cNvPr id="33" name="icon">
             <a:extLst>
               <a:ext uri="{FF2B5EF4-FFF2-40B4-BE49-F238E27FC236}">
-                <a16:creationId xmlns:a16="http://schemas.microsoft.com/office/drawing/2014/main" id="{2987C0D7-940D-184B-8211-17FC166BA5DB}"/>
+                <a16:creationId xmlns:a16="http://schemas.microsoft.com/office/drawing/2014/main" id="{D2D5845E-CCE1-3A71-A70A-B7C6B6DEC1A8}"/>
               </a:ext>
             </a:extLst>
           </p:cNvPr>
@@ -43124,7 +43140,7 @@
           <p:cNvPr id="3" name="icon">
             <a:extLst>
               <a:ext uri="{FF2B5EF4-FFF2-40B4-BE49-F238E27FC236}">
-                <a16:creationId xmlns:a16="http://schemas.microsoft.com/office/drawing/2014/main" id="{E9B8B186-D974-0978-5739-6C872FB487FE}"/>
+                <a16:creationId xmlns:a16="http://schemas.microsoft.com/office/drawing/2014/main" id="{B639ECC8-2AF6-45CF-E978-407DEB399464}"/>
               </a:ext>
             </a:extLst>
           </p:cNvPr>
@@ -43160,7 +43176,7 @@
           <p:cNvPr id="5" name="icon">
             <a:extLst>
               <a:ext uri="{FF2B5EF4-FFF2-40B4-BE49-F238E27FC236}">
-                <a16:creationId xmlns:a16="http://schemas.microsoft.com/office/drawing/2014/main" id="{65BB8241-FDBF-6CC9-00F4-8139810F7C26}"/>
+                <a16:creationId xmlns:a16="http://schemas.microsoft.com/office/drawing/2014/main" id="{2B428B7D-1D3E-C0FA-BF91-5578E78CE542}"/>
               </a:ext>
             </a:extLst>
           </p:cNvPr>
@@ -43196,7 +43212,7 @@
           <p:cNvPr id="7" name="icon">
             <a:extLst>
               <a:ext uri="{FF2B5EF4-FFF2-40B4-BE49-F238E27FC236}">
-                <a16:creationId xmlns:a16="http://schemas.microsoft.com/office/drawing/2014/main" id="{DA8C885C-59B1-D70B-E4BE-7A1BB9A63838}"/>
+                <a16:creationId xmlns:a16="http://schemas.microsoft.com/office/drawing/2014/main" id="{7C1DD288-33E1-6C6F-4665-B390910A1C45}"/>
               </a:ext>
             </a:extLst>
           </p:cNvPr>
@@ -43232,7 +43248,7 @@
           <p:cNvPr id="9" name="icon">
             <a:extLst>
               <a:ext uri="{FF2B5EF4-FFF2-40B4-BE49-F238E27FC236}">
-                <a16:creationId xmlns:a16="http://schemas.microsoft.com/office/drawing/2014/main" id="{37DCA56D-4EFD-3206-59BA-69F3DF5FFAEE}"/>
+                <a16:creationId xmlns:a16="http://schemas.microsoft.com/office/drawing/2014/main" id="{87EE6626-CBBB-F9F6-0561-62C842595260}"/>
               </a:ext>
             </a:extLst>
           </p:cNvPr>
@@ -43268,7 +43284,7 @@
           <p:cNvPr id="11" name="icon">
             <a:extLst>
               <a:ext uri="{FF2B5EF4-FFF2-40B4-BE49-F238E27FC236}">
-                <a16:creationId xmlns:a16="http://schemas.microsoft.com/office/drawing/2014/main" id="{4F4FC907-E6F9-6F18-1A4A-B69A4A683F61}"/>
+                <a16:creationId xmlns:a16="http://schemas.microsoft.com/office/drawing/2014/main" id="{B7D77599-B28A-BE2D-F79D-D9F464304D40}"/>
               </a:ext>
             </a:extLst>
           </p:cNvPr>

</xml_diff>

<commit_message>
Update live demo URL to taptrace-abmd.onrender.com
</commit_message>
<xml_diff>
--- a/submission/TIET_TapTrace.pptx
+++ b/submission/TIET_TapTrace.pptx
@@ -300,7 +300,7 @@
             </c:spPr>
             <c:extLst>
               <c:ext xmlns:c16="http://schemas.microsoft.com/office/drawing/2014/chart" uri="{C3380CC4-5D6E-409C-BE32-E72D297353CC}">
-                <c16:uniqueId val="{00000001-2B4E-40EE-A626-FF55BF1396FF}"/>
+                <c16:uniqueId val="{00000001-F88C-4D99-8FDC-47310BD78BBA}"/>
               </c:ext>
             </c:extLst>
           </c:dPt>
@@ -315,7 +315,7 @@
             </c:spPr>
             <c:extLst>
               <c:ext xmlns:c16="http://schemas.microsoft.com/office/drawing/2014/chart" uri="{C3380CC4-5D6E-409C-BE32-E72D297353CC}">
-                <c16:uniqueId val="{00000003-2B4E-40EE-A626-FF55BF1396FF}"/>
+                <c16:uniqueId val="{00000003-F88C-4D99-8FDC-47310BD78BBA}"/>
               </c:ext>
             </c:extLst>
           </c:dPt>
@@ -330,7 +330,7 @@
             </c:spPr>
             <c:extLst>
               <c:ext xmlns:c16="http://schemas.microsoft.com/office/drawing/2014/chart" uri="{C3380CC4-5D6E-409C-BE32-E72D297353CC}">
-                <c16:uniqueId val="{00000005-2B4E-40EE-A626-FF55BF1396FF}"/>
+                <c16:uniqueId val="{00000005-F88C-4D99-8FDC-47310BD78BBA}"/>
               </c:ext>
             </c:extLst>
           </c:dPt>
@@ -345,7 +345,7 @@
             </c:spPr>
             <c:extLst>
               <c:ext xmlns:c16="http://schemas.microsoft.com/office/drawing/2014/chart" uri="{C3380CC4-5D6E-409C-BE32-E72D297353CC}">
-                <c16:uniqueId val="{00000007-2B4E-40EE-A626-FF55BF1396FF}"/>
+                <c16:uniqueId val="{00000007-F88C-4D99-8FDC-47310BD78BBA}"/>
               </c:ext>
             </c:extLst>
           </c:dPt>
@@ -429,7 +429,7 @@
           </c:val>
           <c:extLst>
             <c:ext xmlns:c16="http://schemas.microsoft.com/office/drawing/2014/chart" uri="{C3380CC4-5D6E-409C-BE32-E72D297353CC}">
-              <c16:uniqueId val="{00000008-2B4E-40EE-A626-FF55BF1396FF}"/>
+              <c16:uniqueId val="{00000008-F88C-4D99-8FDC-47310BD78BBA}"/>
             </c:ext>
           </c:extLst>
         </c:ser>
@@ -580,7 +580,7 @@
             </c:spPr>
             <c:extLst>
               <c:ext xmlns:c16="http://schemas.microsoft.com/office/drawing/2014/chart" uri="{C3380CC4-5D6E-409C-BE32-E72D297353CC}">
-                <c16:uniqueId val="{00000001-D58B-4FB7-B73A-0C666BE55702}"/>
+                <c16:uniqueId val="{00000001-E838-420A-BA78-B12484192D31}"/>
               </c:ext>
             </c:extLst>
           </c:dPt>
@@ -595,7 +595,7 @@
             </c:spPr>
             <c:extLst>
               <c:ext xmlns:c16="http://schemas.microsoft.com/office/drawing/2014/chart" uri="{C3380CC4-5D6E-409C-BE32-E72D297353CC}">
-                <c16:uniqueId val="{00000003-D58B-4FB7-B73A-0C666BE55702}"/>
+                <c16:uniqueId val="{00000003-E838-420A-BA78-B12484192D31}"/>
               </c:ext>
             </c:extLst>
           </c:dPt>
@@ -610,7 +610,7 @@
             </c:spPr>
             <c:extLst>
               <c:ext xmlns:c16="http://schemas.microsoft.com/office/drawing/2014/chart" uri="{C3380CC4-5D6E-409C-BE32-E72D297353CC}">
-                <c16:uniqueId val="{00000005-D58B-4FB7-B73A-0C666BE55702}"/>
+                <c16:uniqueId val="{00000005-E838-420A-BA78-B12484192D31}"/>
               </c:ext>
             </c:extLst>
           </c:dPt>
@@ -625,7 +625,7 @@
             </c:spPr>
             <c:extLst>
               <c:ext xmlns:c16="http://schemas.microsoft.com/office/drawing/2014/chart" uri="{C3380CC4-5D6E-409C-BE32-E72D297353CC}">
-                <c16:uniqueId val="{00000007-D58B-4FB7-B73A-0C666BE55702}"/>
+                <c16:uniqueId val="{00000007-E838-420A-BA78-B12484192D31}"/>
               </c:ext>
             </c:extLst>
           </c:dPt>
@@ -709,7 +709,7 @@
           </c:val>
           <c:extLst>
             <c:ext xmlns:c16="http://schemas.microsoft.com/office/drawing/2014/chart" uri="{C3380CC4-5D6E-409C-BE32-E72D297353CC}">
-              <c16:uniqueId val="{00000008-D58B-4FB7-B73A-0C666BE55702}"/>
+              <c16:uniqueId val="{00000008-E838-420A-BA78-B12484192D31}"/>
             </c:ext>
           </c:extLst>
         </c:ser>
@@ -931,7 +931,7 @@
               </c14:invertSolidFillFmt>
             </c:ext>
             <c:ext xmlns:c16="http://schemas.microsoft.com/office/drawing/2014/chart" uri="{C3380CC4-5D6E-409C-BE32-E72D297353CC}">
-              <c16:uniqueId val="{00000000-BC00-40E4-B368-BED54B2AD553}"/>
+              <c16:uniqueId val="{00000000-8C85-4FBE-BE50-8D5DA8F132D3}"/>
             </c:ext>
           </c:extLst>
         </c:ser>
@@ -1032,7 +1032,7 @@
               </c14:invertSolidFillFmt>
             </c:ext>
             <c:ext xmlns:c16="http://schemas.microsoft.com/office/drawing/2014/chart" uri="{C3380CC4-5D6E-409C-BE32-E72D297353CC}">
-              <c16:uniqueId val="{00000001-BC00-40E4-B368-BED54B2AD553}"/>
+              <c16:uniqueId val="{00000001-8C85-4FBE-BE50-8D5DA8F132D3}"/>
             </c:ext>
           </c:extLst>
         </c:ser>
@@ -14773,7 +14773,7 @@
                 </a:solidFill>
                 <a:latin typeface="Segoe UI"/>
               </a:rPr>
-              <a:t>CODE  github.com/Arnav020/Tap-Trace   |   LIVE DEMO  taptrace.onrender.com</a:t>
+              <a:t>CODE  github.com/Arnav020/Tap-Trace   |   LIVE DEMO  taptrace-abmd.onrender.com</a:t>
             </a:r>
           </a:p>
         </p:txBody>
@@ -14783,7 +14783,7 @@
           <p:cNvPr id="3" name="icon">
             <a:extLst>
               <a:ext uri="{FF2B5EF4-FFF2-40B4-BE49-F238E27FC236}">
-                <a16:creationId xmlns:a16="http://schemas.microsoft.com/office/drawing/2014/main" id="{0B583B85-FD95-F7F8-23CD-3DBFE4FFD971}"/>
+                <a16:creationId xmlns:a16="http://schemas.microsoft.com/office/drawing/2014/main" id="{C2567E7A-107A-0393-9C39-FE19BD9B3EF7}"/>
               </a:ext>
             </a:extLst>
           </p:cNvPr>
@@ -14819,7 +14819,7 @@
           <p:cNvPr id="5" name="icon">
             <a:extLst>
               <a:ext uri="{FF2B5EF4-FFF2-40B4-BE49-F238E27FC236}">
-                <a16:creationId xmlns:a16="http://schemas.microsoft.com/office/drawing/2014/main" id="{ACC8B534-578D-981F-2D0F-ADA4E7A37EDD}"/>
+                <a16:creationId xmlns:a16="http://schemas.microsoft.com/office/drawing/2014/main" id="{E27205E1-C386-721D-A647-541344F224AC}"/>
               </a:ext>
             </a:extLst>
           </p:cNvPr>
@@ -14855,7 +14855,7 @@
           <p:cNvPr id="7" name="icon">
             <a:extLst>
               <a:ext uri="{FF2B5EF4-FFF2-40B4-BE49-F238E27FC236}">
-                <a16:creationId xmlns:a16="http://schemas.microsoft.com/office/drawing/2014/main" id="{D78F132A-64FB-ECFE-90B8-72358678ACAA}"/>
+                <a16:creationId xmlns:a16="http://schemas.microsoft.com/office/drawing/2014/main" id="{78B2CAAE-3838-FE91-EF15-72F7B65E22CF}"/>
               </a:ext>
             </a:extLst>
           </p:cNvPr>
@@ -14891,7 +14891,7 @@
           <p:cNvPr id="9" name="icon">
             <a:extLst>
               <a:ext uri="{FF2B5EF4-FFF2-40B4-BE49-F238E27FC236}">
-                <a16:creationId xmlns:a16="http://schemas.microsoft.com/office/drawing/2014/main" id="{5A850024-1775-6627-56F3-20CD02EF6377}"/>
+                <a16:creationId xmlns:a16="http://schemas.microsoft.com/office/drawing/2014/main" id="{9327A067-A673-294A-E546-8843DA14EA77}"/>
               </a:ext>
             </a:extLst>
           </p:cNvPr>
@@ -17029,7 +17029,7 @@
           <p:cNvPr id="3" name="icon">
             <a:extLst>
               <a:ext uri="{FF2B5EF4-FFF2-40B4-BE49-F238E27FC236}">
-                <a16:creationId xmlns:a16="http://schemas.microsoft.com/office/drawing/2014/main" id="{C86DD8C8-2284-6FA5-CA59-D7811B4A422E}"/>
+                <a16:creationId xmlns:a16="http://schemas.microsoft.com/office/drawing/2014/main" id="{6C4848D3-4CE9-70FA-EF5E-F1C26362AFF8}"/>
               </a:ext>
             </a:extLst>
           </p:cNvPr>
@@ -17065,7 +17065,7 @@
           <p:cNvPr id="5" name="icon">
             <a:extLst>
               <a:ext uri="{FF2B5EF4-FFF2-40B4-BE49-F238E27FC236}">
-                <a16:creationId xmlns:a16="http://schemas.microsoft.com/office/drawing/2014/main" id="{85F91D8E-5E9C-3C34-9409-2728C553F31E}"/>
+                <a16:creationId xmlns:a16="http://schemas.microsoft.com/office/drawing/2014/main" id="{9403191D-5207-DA9D-C96D-4D7CEDE34C08}"/>
               </a:ext>
             </a:extLst>
           </p:cNvPr>
@@ -17101,7 +17101,7 @@
           <p:cNvPr id="7" name="icon">
             <a:extLst>
               <a:ext uri="{FF2B5EF4-FFF2-40B4-BE49-F238E27FC236}">
-                <a16:creationId xmlns:a16="http://schemas.microsoft.com/office/drawing/2014/main" id="{B4A7C590-028B-75BA-6622-05F0502FCFBE}"/>
+                <a16:creationId xmlns:a16="http://schemas.microsoft.com/office/drawing/2014/main" id="{BC9968B7-296C-8E58-B06A-E46F9FB54D46}"/>
               </a:ext>
             </a:extLst>
           </p:cNvPr>
@@ -17137,7 +17137,7 @@
           <p:cNvPr id="9" name="icon">
             <a:extLst>
               <a:ext uri="{FF2B5EF4-FFF2-40B4-BE49-F238E27FC236}">
-                <a16:creationId xmlns:a16="http://schemas.microsoft.com/office/drawing/2014/main" id="{27B56703-5ECD-43EC-75A3-F839DC024009}"/>
+                <a16:creationId xmlns:a16="http://schemas.microsoft.com/office/drawing/2014/main" id="{7046AA02-63D7-B788-A86E-6CEAA4F52C24}"/>
               </a:ext>
             </a:extLst>
           </p:cNvPr>
@@ -17173,7 +17173,7 @@
           <p:cNvPr id="11" name="icon">
             <a:extLst>
               <a:ext uri="{FF2B5EF4-FFF2-40B4-BE49-F238E27FC236}">
-                <a16:creationId xmlns:a16="http://schemas.microsoft.com/office/drawing/2014/main" id="{2470324C-08FC-F119-7C7E-C1F596CC31E3}"/>
+                <a16:creationId xmlns:a16="http://schemas.microsoft.com/office/drawing/2014/main" id="{4B6E05F8-0170-ED5D-C6D3-B0AC37F0824B}"/>
               </a:ext>
             </a:extLst>
           </p:cNvPr>
@@ -17209,7 +17209,7 @@
           <p:cNvPr id="13" name="icon">
             <a:extLst>
               <a:ext uri="{FF2B5EF4-FFF2-40B4-BE49-F238E27FC236}">
-                <a16:creationId xmlns:a16="http://schemas.microsoft.com/office/drawing/2014/main" id="{7E23C3B3-8BE7-E7E1-BA2C-00AEF28A7F56}"/>
+                <a16:creationId xmlns:a16="http://schemas.microsoft.com/office/drawing/2014/main" id="{A90CEC83-65B0-40E2-8884-0F32B6A53F05}"/>
               </a:ext>
             </a:extLst>
           </p:cNvPr>
@@ -17245,7 +17245,7 @@
           <p:cNvPr id="15" name="icon">
             <a:extLst>
               <a:ext uri="{FF2B5EF4-FFF2-40B4-BE49-F238E27FC236}">
-                <a16:creationId xmlns:a16="http://schemas.microsoft.com/office/drawing/2014/main" id="{E327151B-FDD7-2D17-0F50-78D0983E8CA8}"/>
+                <a16:creationId xmlns:a16="http://schemas.microsoft.com/office/drawing/2014/main" id="{0151355B-9C32-44EE-D28C-FA0F4627AE39}"/>
               </a:ext>
             </a:extLst>
           </p:cNvPr>
@@ -17281,7 +17281,7 @@
           <p:cNvPr id="17" name="icon">
             <a:extLst>
               <a:ext uri="{FF2B5EF4-FFF2-40B4-BE49-F238E27FC236}">
-                <a16:creationId xmlns:a16="http://schemas.microsoft.com/office/drawing/2014/main" id="{9E9EB41C-9D6F-F693-D67F-B3574A21CF04}"/>
+                <a16:creationId xmlns:a16="http://schemas.microsoft.com/office/drawing/2014/main" id="{858D3648-1932-A0EE-D855-1A1BFE883338}"/>
               </a:ext>
             </a:extLst>
           </p:cNvPr>
@@ -17317,7 +17317,7 @@
           <p:cNvPr id="19" name="icon">
             <a:extLst>
               <a:ext uri="{FF2B5EF4-FFF2-40B4-BE49-F238E27FC236}">
-                <a16:creationId xmlns:a16="http://schemas.microsoft.com/office/drawing/2014/main" id="{CFCB1AA5-EBCE-BDFA-8C57-6130F7904C51}"/>
+                <a16:creationId xmlns:a16="http://schemas.microsoft.com/office/drawing/2014/main" id="{4932AE55-EC9E-F46C-AF93-E58B3583114F}"/>
               </a:ext>
             </a:extLst>
           </p:cNvPr>
@@ -17353,7 +17353,7 @@
           <p:cNvPr id="21" name="icon">
             <a:extLst>
               <a:ext uri="{FF2B5EF4-FFF2-40B4-BE49-F238E27FC236}">
-                <a16:creationId xmlns:a16="http://schemas.microsoft.com/office/drawing/2014/main" id="{B37A3333-604C-8574-D1AD-A16D706B2F0C}"/>
+                <a16:creationId xmlns:a16="http://schemas.microsoft.com/office/drawing/2014/main" id="{CAAAC6BF-824D-4E08-7C36-3BDE5D6DD1E2}"/>
               </a:ext>
             </a:extLst>
           </p:cNvPr>
@@ -17389,7 +17389,7 @@
           <p:cNvPr id="23" name="icon">
             <a:extLst>
               <a:ext uri="{FF2B5EF4-FFF2-40B4-BE49-F238E27FC236}">
-                <a16:creationId xmlns:a16="http://schemas.microsoft.com/office/drawing/2014/main" id="{33B4C9F2-A2B1-672D-A676-625674D7D521}"/>
+                <a16:creationId xmlns:a16="http://schemas.microsoft.com/office/drawing/2014/main" id="{28D435CA-271A-39C6-6DD1-8E2E8B3A2A39}"/>
               </a:ext>
             </a:extLst>
           </p:cNvPr>
@@ -17425,7 +17425,7 @@
           <p:cNvPr id="25" name="icon">
             <a:extLst>
               <a:ext uri="{FF2B5EF4-FFF2-40B4-BE49-F238E27FC236}">
-                <a16:creationId xmlns:a16="http://schemas.microsoft.com/office/drawing/2014/main" id="{9EA8116D-7B57-9ABD-94BA-04284B41730F}"/>
+                <a16:creationId xmlns:a16="http://schemas.microsoft.com/office/drawing/2014/main" id="{8B36EEE9-4F6B-389C-5AF6-A077ABA1DCAA}"/>
               </a:ext>
             </a:extLst>
           </p:cNvPr>
@@ -17461,7 +17461,7 @@
           <p:cNvPr id="27" name="icon">
             <a:extLst>
               <a:ext uri="{FF2B5EF4-FFF2-40B4-BE49-F238E27FC236}">
-                <a16:creationId xmlns:a16="http://schemas.microsoft.com/office/drawing/2014/main" id="{16F17542-B93A-03A2-8137-0BF896D62098}"/>
+                <a16:creationId xmlns:a16="http://schemas.microsoft.com/office/drawing/2014/main" id="{64F8587A-14F3-6812-A53E-7A8DE6278DF9}"/>
               </a:ext>
             </a:extLst>
           </p:cNvPr>
@@ -17497,7 +17497,7 @@
           <p:cNvPr id="29" name="icon">
             <a:extLst>
               <a:ext uri="{FF2B5EF4-FFF2-40B4-BE49-F238E27FC236}">
-                <a16:creationId xmlns:a16="http://schemas.microsoft.com/office/drawing/2014/main" id="{862AD4DD-6974-8840-8C8F-D088388419AE}"/>
+                <a16:creationId xmlns:a16="http://schemas.microsoft.com/office/drawing/2014/main" id="{475CA777-CD55-0A65-CB7B-6364DA983CB4}"/>
               </a:ext>
             </a:extLst>
           </p:cNvPr>
@@ -18152,7 +18152,7 @@
                 </a:solidFill>
                 <a:latin typeface="Segoe UI"/>
               </a:rPr>
-              <a:t>github.com/Arnav020/Tap-Trace  ·  live: taptrace.onrender.com</a:t>
+              <a:t>github.com/Arnav020/Tap-Trace  ·  live: taptrace-abmd.onrender.com</a:t>
             </a:r>
           </a:p>
         </p:txBody>
@@ -19364,7 +19364,7 @@
           <p:cNvPr id="3" name="icon">
             <a:extLst>
               <a:ext uri="{FF2B5EF4-FFF2-40B4-BE49-F238E27FC236}">
-                <a16:creationId xmlns:a16="http://schemas.microsoft.com/office/drawing/2014/main" id="{33A2B87F-BDF0-1FCA-A36E-5413A44713E4}"/>
+                <a16:creationId xmlns:a16="http://schemas.microsoft.com/office/drawing/2014/main" id="{F50EC19B-BBAB-CC84-713C-B0AEEF75C3AF}"/>
               </a:ext>
             </a:extLst>
           </p:cNvPr>
@@ -19400,7 +19400,7 @@
           <p:cNvPr id="5" name="icon">
             <a:extLst>
               <a:ext uri="{FF2B5EF4-FFF2-40B4-BE49-F238E27FC236}">
-                <a16:creationId xmlns:a16="http://schemas.microsoft.com/office/drawing/2014/main" id="{F49B5164-73EC-4DA1-FE1B-47C2F61DE89E}"/>
+                <a16:creationId xmlns:a16="http://schemas.microsoft.com/office/drawing/2014/main" id="{59323775-8093-507E-C5C5-25BF5C57AEC3}"/>
               </a:ext>
             </a:extLst>
           </p:cNvPr>
@@ -19436,7 +19436,7 @@
           <p:cNvPr id="7" name="icon">
             <a:extLst>
               <a:ext uri="{FF2B5EF4-FFF2-40B4-BE49-F238E27FC236}">
-                <a16:creationId xmlns:a16="http://schemas.microsoft.com/office/drawing/2014/main" id="{248165E2-8DC3-7EBA-3546-48479EC7B182}"/>
+                <a16:creationId xmlns:a16="http://schemas.microsoft.com/office/drawing/2014/main" id="{78D9BB03-A8E5-72D5-E235-4BACB6053545}"/>
               </a:ext>
             </a:extLst>
           </p:cNvPr>
@@ -19472,7 +19472,7 @@
           <p:cNvPr id="9" name="icon">
             <a:extLst>
               <a:ext uri="{FF2B5EF4-FFF2-40B4-BE49-F238E27FC236}">
-                <a16:creationId xmlns:a16="http://schemas.microsoft.com/office/drawing/2014/main" id="{00C21327-E81D-A50B-501E-7A26E75DDB96}"/>
+                <a16:creationId xmlns:a16="http://schemas.microsoft.com/office/drawing/2014/main" id="{BCC65CEA-EC94-FA15-C76E-723C9E6629D0}"/>
               </a:ext>
             </a:extLst>
           </p:cNvPr>
@@ -19508,7 +19508,7 @@
           <p:cNvPr id="11" name="icon">
             <a:extLst>
               <a:ext uri="{FF2B5EF4-FFF2-40B4-BE49-F238E27FC236}">
-                <a16:creationId xmlns:a16="http://schemas.microsoft.com/office/drawing/2014/main" id="{21D42B11-957B-4337-596F-9E1CB494896C}"/>
+                <a16:creationId xmlns:a16="http://schemas.microsoft.com/office/drawing/2014/main" id="{28041DA7-DADA-B197-5E64-7AA53880FAF2}"/>
               </a:ext>
             </a:extLst>
           </p:cNvPr>
@@ -19544,7 +19544,7 @@
           <p:cNvPr id="13" name="icon">
             <a:extLst>
               <a:ext uri="{FF2B5EF4-FFF2-40B4-BE49-F238E27FC236}">
-                <a16:creationId xmlns:a16="http://schemas.microsoft.com/office/drawing/2014/main" id="{307C50B6-7660-B22E-5978-3A434505A801}"/>
+                <a16:creationId xmlns:a16="http://schemas.microsoft.com/office/drawing/2014/main" id="{287422F2-9532-B8C2-E5F6-4217A37B4E82}"/>
               </a:ext>
             </a:extLst>
           </p:cNvPr>
@@ -20174,7 +20174,7 @@
                 </a:solidFill>
                 <a:latin typeface="Segoe UI"/>
               </a:rPr>
-              <a:t>ARNAV JOSHI  ·  ajoshi4_be23@thapar.edu  ·  THAPAR INSTITUTE OF ENGINEERING &amp; TECHNOLOGY  ·  github.com/Arnav020/Tap-Trace  ·  LIVE taptrace.onrender.com</a:t>
+              <a:t>ARNAV JOSHI  ·  ajoshi4_be23@thapar.edu  ·  THAPAR INSTITUTE OF ENGINEERING &amp; TECHNOLOGY  ·  github.com/Arnav020/Tap-Trace  ·  LIVE taptrace-abmd.onrender.com</a:t>
             </a:r>
           </a:p>
         </p:txBody>
@@ -22802,7 +22802,7 @@
           <p:cNvPr id="3" name="icon">
             <a:extLst>
               <a:ext uri="{FF2B5EF4-FFF2-40B4-BE49-F238E27FC236}">
-                <a16:creationId xmlns:a16="http://schemas.microsoft.com/office/drawing/2014/main" id="{C5B66C33-6D62-EF9C-D830-CC8D9AB9B11D}"/>
+                <a16:creationId xmlns:a16="http://schemas.microsoft.com/office/drawing/2014/main" id="{A0EC2B54-1E7B-7445-0D4E-2BB3DAE7692E}"/>
               </a:ext>
             </a:extLst>
           </p:cNvPr>
@@ -22838,7 +22838,7 @@
           <p:cNvPr id="5" name="icon">
             <a:extLst>
               <a:ext uri="{FF2B5EF4-FFF2-40B4-BE49-F238E27FC236}">
-                <a16:creationId xmlns:a16="http://schemas.microsoft.com/office/drawing/2014/main" id="{85B3B52B-B93A-02F4-5CDF-75A95661D457}"/>
+                <a16:creationId xmlns:a16="http://schemas.microsoft.com/office/drawing/2014/main" id="{28954292-2A20-78DB-7040-A99DAB256CEC}"/>
               </a:ext>
             </a:extLst>
           </p:cNvPr>
@@ -22874,7 +22874,7 @@
           <p:cNvPr id="7" name="icon">
             <a:extLst>
               <a:ext uri="{FF2B5EF4-FFF2-40B4-BE49-F238E27FC236}">
-                <a16:creationId xmlns:a16="http://schemas.microsoft.com/office/drawing/2014/main" id="{4B95E9FC-3EAF-DD18-7E0F-B9EF331F3FBD}"/>
+                <a16:creationId xmlns:a16="http://schemas.microsoft.com/office/drawing/2014/main" id="{7FC62366-5441-5748-63FF-2EE8199378DE}"/>
               </a:ext>
             </a:extLst>
           </p:cNvPr>
@@ -22910,7 +22910,7 @@
           <p:cNvPr id="9" name="icon">
             <a:extLst>
               <a:ext uri="{FF2B5EF4-FFF2-40B4-BE49-F238E27FC236}">
-                <a16:creationId xmlns:a16="http://schemas.microsoft.com/office/drawing/2014/main" id="{12A2038B-530A-4467-1E68-8F5C8A8BA8F2}"/>
+                <a16:creationId xmlns:a16="http://schemas.microsoft.com/office/drawing/2014/main" id="{BF371556-2344-36C5-632D-A3E48C35E50A}"/>
               </a:ext>
             </a:extLst>
           </p:cNvPr>
@@ -22946,7 +22946,7 @@
           <p:cNvPr id="11" name="icon">
             <a:extLst>
               <a:ext uri="{FF2B5EF4-FFF2-40B4-BE49-F238E27FC236}">
-                <a16:creationId xmlns:a16="http://schemas.microsoft.com/office/drawing/2014/main" id="{65DFEF2B-9800-6933-5EF9-7C6D375D5393}"/>
+                <a16:creationId xmlns:a16="http://schemas.microsoft.com/office/drawing/2014/main" id="{97E4FC26-E24A-B117-B007-63BCDF683E39}"/>
               </a:ext>
             </a:extLst>
           </p:cNvPr>
@@ -25540,7 +25540,7 @@
           <p:cNvPr id="3" name="icon">
             <a:extLst>
               <a:ext uri="{FF2B5EF4-FFF2-40B4-BE49-F238E27FC236}">
-                <a16:creationId xmlns:a16="http://schemas.microsoft.com/office/drawing/2014/main" id="{17B2B313-F2FD-AE1C-E451-C85D65BA1184}"/>
+                <a16:creationId xmlns:a16="http://schemas.microsoft.com/office/drawing/2014/main" id="{A2C72161-D42B-68E1-46C9-553394C45599}"/>
               </a:ext>
             </a:extLst>
           </p:cNvPr>
@@ -25576,7 +25576,7 @@
           <p:cNvPr id="5" name="icon">
             <a:extLst>
               <a:ext uri="{FF2B5EF4-FFF2-40B4-BE49-F238E27FC236}">
-                <a16:creationId xmlns:a16="http://schemas.microsoft.com/office/drawing/2014/main" id="{F31B72BB-C61A-F840-AE4F-1A960F405B2E}"/>
+                <a16:creationId xmlns:a16="http://schemas.microsoft.com/office/drawing/2014/main" id="{3C685D3B-D75D-0A76-8C1C-D4A44279E01C}"/>
               </a:ext>
             </a:extLst>
           </p:cNvPr>
@@ -25612,7 +25612,7 @@
           <p:cNvPr id="7" name="icon">
             <a:extLst>
               <a:ext uri="{FF2B5EF4-FFF2-40B4-BE49-F238E27FC236}">
-                <a16:creationId xmlns:a16="http://schemas.microsoft.com/office/drawing/2014/main" id="{CEDC2F07-CF34-DFA5-BFAD-AF33EC800B38}"/>
+                <a16:creationId xmlns:a16="http://schemas.microsoft.com/office/drawing/2014/main" id="{3532D5CF-32B8-D297-8DAB-BE7F1B1D40CF}"/>
               </a:ext>
             </a:extLst>
           </p:cNvPr>
@@ -25648,7 +25648,7 @@
           <p:cNvPr id="9" name="icon">
             <a:extLst>
               <a:ext uri="{FF2B5EF4-FFF2-40B4-BE49-F238E27FC236}">
-                <a16:creationId xmlns:a16="http://schemas.microsoft.com/office/drawing/2014/main" id="{77080900-6D66-EB06-F87E-166C7823902E}"/>
+                <a16:creationId xmlns:a16="http://schemas.microsoft.com/office/drawing/2014/main" id="{9C47E511-4316-1E58-C02B-3747BD61669B}"/>
               </a:ext>
             </a:extLst>
           </p:cNvPr>
@@ -25684,7 +25684,7 @@
           <p:cNvPr id="11" name="icon">
             <a:extLst>
               <a:ext uri="{FF2B5EF4-FFF2-40B4-BE49-F238E27FC236}">
-                <a16:creationId xmlns:a16="http://schemas.microsoft.com/office/drawing/2014/main" id="{386948EC-828B-D5EB-FE38-83601FA602A1}"/>
+                <a16:creationId xmlns:a16="http://schemas.microsoft.com/office/drawing/2014/main" id="{1F544AEC-A57C-5348-65B0-CF828A8055B5}"/>
               </a:ext>
             </a:extLst>
           </p:cNvPr>
@@ -25720,7 +25720,7 @@
           <p:cNvPr id="13" name="icon">
             <a:extLst>
               <a:ext uri="{FF2B5EF4-FFF2-40B4-BE49-F238E27FC236}">
-                <a16:creationId xmlns:a16="http://schemas.microsoft.com/office/drawing/2014/main" id="{C142DD4D-1C57-B871-6C1E-DBED6C1193FD}"/>
+                <a16:creationId xmlns:a16="http://schemas.microsoft.com/office/drawing/2014/main" id="{8725F2B9-A5DA-2986-8507-E1EAB5122838}"/>
               </a:ext>
             </a:extLst>
           </p:cNvPr>
@@ -25756,7 +25756,7 @@
           <p:cNvPr id="15" name="icon">
             <a:extLst>
               <a:ext uri="{FF2B5EF4-FFF2-40B4-BE49-F238E27FC236}">
-                <a16:creationId xmlns:a16="http://schemas.microsoft.com/office/drawing/2014/main" id="{59036254-3EF0-BA8B-CDCE-B4291EE4180A}"/>
+                <a16:creationId xmlns:a16="http://schemas.microsoft.com/office/drawing/2014/main" id="{1A487375-B4F3-A895-941C-C83FC3BE0480}"/>
               </a:ext>
             </a:extLst>
           </p:cNvPr>
@@ -25792,7 +25792,7 @@
           <p:cNvPr id="17" name="icon">
             <a:extLst>
               <a:ext uri="{FF2B5EF4-FFF2-40B4-BE49-F238E27FC236}">
-                <a16:creationId xmlns:a16="http://schemas.microsoft.com/office/drawing/2014/main" id="{2AC3E651-92AF-1835-B55A-63D36A89CC1D}"/>
+                <a16:creationId xmlns:a16="http://schemas.microsoft.com/office/drawing/2014/main" id="{9A3F07DD-6159-BAE9-376C-A57C85B5F1E6}"/>
               </a:ext>
             </a:extLst>
           </p:cNvPr>
@@ -25828,7 +25828,7 @@
           <p:cNvPr id="19" name="icon">
             <a:extLst>
               <a:ext uri="{FF2B5EF4-FFF2-40B4-BE49-F238E27FC236}">
-                <a16:creationId xmlns:a16="http://schemas.microsoft.com/office/drawing/2014/main" id="{6BB3065A-D6E0-04BE-A7B5-437218289D3F}"/>
+                <a16:creationId xmlns:a16="http://schemas.microsoft.com/office/drawing/2014/main" id="{5392B2D9-2FE7-E1BE-849E-950BF3AD8532}"/>
               </a:ext>
             </a:extLst>
           </p:cNvPr>
@@ -25864,7 +25864,7 @@
           <p:cNvPr id="21" name="icon">
             <a:extLst>
               <a:ext uri="{FF2B5EF4-FFF2-40B4-BE49-F238E27FC236}">
-                <a16:creationId xmlns:a16="http://schemas.microsoft.com/office/drawing/2014/main" id="{44F07D6A-FCBC-0077-4169-82C9F05B2C69}"/>
+                <a16:creationId xmlns:a16="http://schemas.microsoft.com/office/drawing/2014/main" id="{E0088A9A-E7FD-E37F-D3A5-9B7957183DDA}"/>
               </a:ext>
             </a:extLst>
           </p:cNvPr>
@@ -25900,7 +25900,7 @@
           <p:cNvPr id="23" name="icon">
             <a:extLst>
               <a:ext uri="{FF2B5EF4-FFF2-40B4-BE49-F238E27FC236}">
-                <a16:creationId xmlns:a16="http://schemas.microsoft.com/office/drawing/2014/main" id="{EB052D95-29B8-9726-E05E-F09AB2B01F89}"/>
+                <a16:creationId xmlns:a16="http://schemas.microsoft.com/office/drawing/2014/main" id="{EE81435F-2501-5559-3BFC-1D9846AC54A7}"/>
               </a:ext>
             </a:extLst>
           </p:cNvPr>
@@ -25936,7 +25936,7 @@
           <p:cNvPr id="25" name="icon">
             <a:extLst>
               <a:ext uri="{FF2B5EF4-FFF2-40B4-BE49-F238E27FC236}">
-                <a16:creationId xmlns:a16="http://schemas.microsoft.com/office/drawing/2014/main" id="{52946799-B482-4831-6107-3574B3BAC217}"/>
+                <a16:creationId xmlns:a16="http://schemas.microsoft.com/office/drawing/2014/main" id="{8A06EBCA-6230-D290-347E-2C04102A1BCC}"/>
               </a:ext>
             </a:extLst>
           </p:cNvPr>
@@ -25972,7 +25972,7 @@
           <p:cNvPr id="27" name="icon">
             <a:extLst>
               <a:ext uri="{FF2B5EF4-FFF2-40B4-BE49-F238E27FC236}">
-                <a16:creationId xmlns:a16="http://schemas.microsoft.com/office/drawing/2014/main" id="{2E52B3CB-13B4-56A1-FB3C-769AC8BC6161}"/>
+                <a16:creationId xmlns:a16="http://schemas.microsoft.com/office/drawing/2014/main" id="{74E4AD0B-4460-F220-0BE6-C101ECC255F2}"/>
               </a:ext>
             </a:extLst>
           </p:cNvPr>
@@ -26008,7 +26008,7 @@
           <p:cNvPr id="29" name="icon">
             <a:extLst>
               <a:ext uri="{FF2B5EF4-FFF2-40B4-BE49-F238E27FC236}">
-                <a16:creationId xmlns:a16="http://schemas.microsoft.com/office/drawing/2014/main" id="{85537767-F168-57DB-EEC0-83C8E594F4C3}"/>
+                <a16:creationId xmlns:a16="http://schemas.microsoft.com/office/drawing/2014/main" id="{372CC006-529D-A7B2-4573-D7A93EA76B2E}"/>
               </a:ext>
             </a:extLst>
           </p:cNvPr>
@@ -26044,7 +26044,7 @@
           <p:cNvPr id="31" name="icon">
             <a:extLst>
               <a:ext uri="{FF2B5EF4-FFF2-40B4-BE49-F238E27FC236}">
-                <a16:creationId xmlns:a16="http://schemas.microsoft.com/office/drawing/2014/main" id="{8BFDEA4A-AF24-4800-53F5-0323CEAB9D74}"/>
+                <a16:creationId xmlns:a16="http://schemas.microsoft.com/office/drawing/2014/main" id="{C90025AA-5FBC-3314-55D2-B8A001A2DFBE}"/>
               </a:ext>
             </a:extLst>
           </p:cNvPr>
@@ -26080,7 +26080,7 @@
           <p:cNvPr id="33" name="icon">
             <a:extLst>
               <a:ext uri="{FF2B5EF4-FFF2-40B4-BE49-F238E27FC236}">
-                <a16:creationId xmlns:a16="http://schemas.microsoft.com/office/drawing/2014/main" id="{281AB899-47BF-F230-3C82-1FDCCC0D707F}"/>
+                <a16:creationId xmlns:a16="http://schemas.microsoft.com/office/drawing/2014/main" id="{1C673357-58B4-675F-BF23-958D46369A55}"/>
               </a:ext>
             </a:extLst>
           </p:cNvPr>
@@ -26116,7 +26116,7 @@
           <p:cNvPr id="35" name="icon">
             <a:extLst>
               <a:ext uri="{FF2B5EF4-FFF2-40B4-BE49-F238E27FC236}">
-                <a16:creationId xmlns:a16="http://schemas.microsoft.com/office/drawing/2014/main" id="{DC314057-733E-9CC3-F460-42848D46F0F3}"/>
+                <a16:creationId xmlns:a16="http://schemas.microsoft.com/office/drawing/2014/main" id="{5AE901B2-4D19-2444-BD34-C8C5C2BC3CEC}"/>
               </a:ext>
             </a:extLst>
           </p:cNvPr>
@@ -26152,7 +26152,7 @@
           <p:cNvPr id="37" name="icon">
             <a:extLst>
               <a:ext uri="{FF2B5EF4-FFF2-40B4-BE49-F238E27FC236}">
-                <a16:creationId xmlns:a16="http://schemas.microsoft.com/office/drawing/2014/main" id="{69A46BE4-D06F-0910-1355-CE3505B1DBAD}"/>
+                <a16:creationId xmlns:a16="http://schemas.microsoft.com/office/drawing/2014/main" id="{EA3CA0C5-9EDA-13CB-1AEF-C1EEA7A3227B}"/>
               </a:ext>
             </a:extLst>
           </p:cNvPr>
@@ -26188,7 +26188,7 @@
           <p:cNvPr id="39" name="icon">
             <a:extLst>
               <a:ext uri="{FF2B5EF4-FFF2-40B4-BE49-F238E27FC236}">
-                <a16:creationId xmlns:a16="http://schemas.microsoft.com/office/drawing/2014/main" id="{E7DF67A1-A013-EBE1-5008-F498DC807132}"/>
+                <a16:creationId xmlns:a16="http://schemas.microsoft.com/office/drawing/2014/main" id="{CB7B8649-7190-8644-8193-D70079FB6BEC}"/>
               </a:ext>
             </a:extLst>
           </p:cNvPr>
@@ -26224,7 +26224,7 @@
           <p:cNvPr id="41" name="icon">
             <a:extLst>
               <a:ext uri="{FF2B5EF4-FFF2-40B4-BE49-F238E27FC236}">
-                <a16:creationId xmlns:a16="http://schemas.microsoft.com/office/drawing/2014/main" id="{C73ADA6E-C192-35D8-3342-EB8089A2502C}"/>
+                <a16:creationId xmlns:a16="http://schemas.microsoft.com/office/drawing/2014/main" id="{9ABB2F92-3C51-173C-8DC8-8FB97897070C}"/>
               </a:ext>
             </a:extLst>
           </p:cNvPr>
@@ -29954,7 +29954,7 @@
           <p:cNvPr id="3" name="icon">
             <a:extLst>
               <a:ext uri="{FF2B5EF4-FFF2-40B4-BE49-F238E27FC236}">
-                <a16:creationId xmlns:a16="http://schemas.microsoft.com/office/drawing/2014/main" id="{C3142F2A-1511-FB20-8B08-C8EC7D9A3EE7}"/>
+                <a16:creationId xmlns:a16="http://schemas.microsoft.com/office/drawing/2014/main" id="{89ABD4A1-678B-059F-0112-E58BAA53AB87}"/>
               </a:ext>
             </a:extLst>
           </p:cNvPr>
@@ -29990,7 +29990,7 @@
           <p:cNvPr id="5" name="icon">
             <a:extLst>
               <a:ext uri="{FF2B5EF4-FFF2-40B4-BE49-F238E27FC236}">
-                <a16:creationId xmlns:a16="http://schemas.microsoft.com/office/drawing/2014/main" id="{DAE5FB8C-66C1-8380-291B-870A9E5C4C05}"/>
+                <a16:creationId xmlns:a16="http://schemas.microsoft.com/office/drawing/2014/main" id="{91DF5373-2217-A1A8-D7B5-02BA48CF4B06}"/>
               </a:ext>
             </a:extLst>
           </p:cNvPr>
@@ -30026,7 +30026,7 @@
           <p:cNvPr id="7" name="icon">
             <a:extLst>
               <a:ext uri="{FF2B5EF4-FFF2-40B4-BE49-F238E27FC236}">
-                <a16:creationId xmlns:a16="http://schemas.microsoft.com/office/drawing/2014/main" id="{2BB3AE7F-4111-D110-0DA5-08A1FC653994}"/>
+                <a16:creationId xmlns:a16="http://schemas.microsoft.com/office/drawing/2014/main" id="{318F0DF5-60FA-D405-476C-440D2BA5BD97}"/>
               </a:ext>
             </a:extLst>
           </p:cNvPr>
@@ -30062,7 +30062,7 @@
           <p:cNvPr id="9" name="icon">
             <a:extLst>
               <a:ext uri="{FF2B5EF4-FFF2-40B4-BE49-F238E27FC236}">
-                <a16:creationId xmlns:a16="http://schemas.microsoft.com/office/drawing/2014/main" id="{75E0EFA4-E4DC-7C4E-9902-3F8E02F911D2}"/>
+                <a16:creationId xmlns:a16="http://schemas.microsoft.com/office/drawing/2014/main" id="{C3AB3A4E-4FD5-47E2-6D45-A20B82530CB9}"/>
               </a:ext>
             </a:extLst>
           </p:cNvPr>
@@ -30098,7 +30098,7 @@
           <p:cNvPr id="11" name="icon">
             <a:extLst>
               <a:ext uri="{FF2B5EF4-FFF2-40B4-BE49-F238E27FC236}">
-                <a16:creationId xmlns:a16="http://schemas.microsoft.com/office/drawing/2014/main" id="{FAB829A3-CF31-978D-A74A-F79CF309F5FB}"/>
+                <a16:creationId xmlns:a16="http://schemas.microsoft.com/office/drawing/2014/main" id="{6671DEAF-C2E0-FE51-1FBD-73EA0EF592CC}"/>
               </a:ext>
             </a:extLst>
           </p:cNvPr>
@@ -30134,7 +30134,7 @@
           <p:cNvPr id="13" name="icon">
             <a:extLst>
               <a:ext uri="{FF2B5EF4-FFF2-40B4-BE49-F238E27FC236}">
-                <a16:creationId xmlns:a16="http://schemas.microsoft.com/office/drawing/2014/main" id="{B539E6CC-B770-E58E-3C5B-BE70C38FA67D}"/>
+                <a16:creationId xmlns:a16="http://schemas.microsoft.com/office/drawing/2014/main" id="{9DD198AD-96CD-0361-50B6-CB97574D5D5C}"/>
               </a:ext>
             </a:extLst>
           </p:cNvPr>
@@ -30170,7 +30170,7 @@
           <p:cNvPr id="15" name="icon">
             <a:extLst>
               <a:ext uri="{FF2B5EF4-FFF2-40B4-BE49-F238E27FC236}">
-                <a16:creationId xmlns:a16="http://schemas.microsoft.com/office/drawing/2014/main" id="{D07F3C16-8B9E-646E-050A-DA19243C049D}"/>
+                <a16:creationId xmlns:a16="http://schemas.microsoft.com/office/drawing/2014/main" id="{045BF5D4-751D-5197-E38B-89BCD08F40F0}"/>
               </a:ext>
             </a:extLst>
           </p:cNvPr>
@@ -30206,7 +30206,7 @@
           <p:cNvPr id="17" name="icon">
             <a:extLst>
               <a:ext uri="{FF2B5EF4-FFF2-40B4-BE49-F238E27FC236}">
-                <a16:creationId xmlns:a16="http://schemas.microsoft.com/office/drawing/2014/main" id="{3055FFF4-8621-A599-98B3-017511C3D68B}"/>
+                <a16:creationId xmlns:a16="http://schemas.microsoft.com/office/drawing/2014/main" id="{79802A1A-675F-B123-3C7E-2E9CC3FFBB02}"/>
               </a:ext>
             </a:extLst>
           </p:cNvPr>
@@ -30242,7 +30242,7 @@
           <p:cNvPr id="19" name="icon">
             <a:extLst>
               <a:ext uri="{FF2B5EF4-FFF2-40B4-BE49-F238E27FC236}">
-                <a16:creationId xmlns:a16="http://schemas.microsoft.com/office/drawing/2014/main" id="{882CE35B-0EB5-3842-9E1B-1956E6DEA2A3}"/>
+                <a16:creationId xmlns:a16="http://schemas.microsoft.com/office/drawing/2014/main" id="{771DC826-0120-4348-3C57-7CE1BF2F32BD}"/>
               </a:ext>
             </a:extLst>
           </p:cNvPr>
@@ -30278,7 +30278,7 @@
           <p:cNvPr id="21" name="icon">
             <a:extLst>
               <a:ext uri="{FF2B5EF4-FFF2-40B4-BE49-F238E27FC236}">
-                <a16:creationId xmlns:a16="http://schemas.microsoft.com/office/drawing/2014/main" id="{9B5A164D-EF54-CA26-71BA-91240F935B52}"/>
+                <a16:creationId xmlns:a16="http://schemas.microsoft.com/office/drawing/2014/main" id="{AFDB6713-0132-1B30-E32A-E4F2A9264616}"/>
               </a:ext>
             </a:extLst>
           </p:cNvPr>
@@ -30314,7 +30314,7 @@
           <p:cNvPr id="23" name="icon">
             <a:extLst>
               <a:ext uri="{FF2B5EF4-FFF2-40B4-BE49-F238E27FC236}">
-                <a16:creationId xmlns:a16="http://schemas.microsoft.com/office/drawing/2014/main" id="{5D2DCB47-6C1B-AF56-4803-B7592BD0E847}"/>
+                <a16:creationId xmlns:a16="http://schemas.microsoft.com/office/drawing/2014/main" id="{EEBC862A-395E-92F0-9950-88A6E1745C3D}"/>
               </a:ext>
             </a:extLst>
           </p:cNvPr>
@@ -30350,7 +30350,7 @@
           <p:cNvPr id="25" name="icon">
             <a:extLst>
               <a:ext uri="{FF2B5EF4-FFF2-40B4-BE49-F238E27FC236}">
-                <a16:creationId xmlns:a16="http://schemas.microsoft.com/office/drawing/2014/main" id="{F8776D0B-274D-8825-2C4A-B0A28B260BBA}"/>
+                <a16:creationId xmlns:a16="http://schemas.microsoft.com/office/drawing/2014/main" id="{4C6BFB89-9ABB-FC45-689A-5328CC90A41D}"/>
               </a:ext>
             </a:extLst>
           </p:cNvPr>
@@ -30386,7 +30386,7 @@
           <p:cNvPr id="27" name="icon">
             <a:extLst>
               <a:ext uri="{FF2B5EF4-FFF2-40B4-BE49-F238E27FC236}">
-                <a16:creationId xmlns:a16="http://schemas.microsoft.com/office/drawing/2014/main" id="{A8F26973-E351-8C44-2E7B-A31290500C1B}"/>
+                <a16:creationId xmlns:a16="http://schemas.microsoft.com/office/drawing/2014/main" id="{6A57A93A-4523-FC13-472D-00FB1B0E9FF6}"/>
               </a:ext>
             </a:extLst>
           </p:cNvPr>
@@ -30422,7 +30422,7 @@
           <p:cNvPr id="29" name="icon">
             <a:extLst>
               <a:ext uri="{FF2B5EF4-FFF2-40B4-BE49-F238E27FC236}">
-                <a16:creationId xmlns:a16="http://schemas.microsoft.com/office/drawing/2014/main" id="{B9C3500E-4246-9EBA-E40C-77220E84879B}"/>
+                <a16:creationId xmlns:a16="http://schemas.microsoft.com/office/drawing/2014/main" id="{2BFEEF51-8FD4-1120-7A8C-250563203A49}"/>
               </a:ext>
             </a:extLst>
           </p:cNvPr>
@@ -30458,7 +30458,7 @@
           <p:cNvPr id="31" name="icon">
             <a:extLst>
               <a:ext uri="{FF2B5EF4-FFF2-40B4-BE49-F238E27FC236}">
-                <a16:creationId xmlns:a16="http://schemas.microsoft.com/office/drawing/2014/main" id="{90D60023-4FF9-9E91-1CCD-58FCBDC55EEB}"/>
+                <a16:creationId xmlns:a16="http://schemas.microsoft.com/office/drawing/2014/main" id="{B74D6EC9-F296-6A69-ED43-A3B252194274}"/>
               </a:ext>
             </a:extLst>
           </p:cNvPr>
@@ -30494,7 +30494,7 @@
           <p:cNvPr id="33" name="icon">
             <a:extLst>
               <a:ext uri="{FF2B5EF4-FFF2-40B4-BE49-F238E27FC236}">
-                <a16:creationId xmlns:a16="http://schemas.microsoft.com/office/drawing/2014/main" id="{9AAA8C94-9A9C-8242-45A0-7EDEFEFF5541}"/>
+                <a16:creationId xmlns:a16="http://schemas.microsoft.com/office/drawing/2014/main" id="{82A11975-BE8E-30C0-D592-D37741686FAD}"/>
               </a:ext>
             </a:extLst>
           </p:cNvPr>
@@ -30530,7 +30530,7 @@
           <p:cNvPr id="35" name="icon">
             <a:extLst>
               <a:ext uri="{FF2B5EF4-FFF2-40B4-BE49-F238E27FC236}">
-                <a16:creationId xmlns:a16="http://schemas.microsoft.com/office/drawing/2014/main" id="{9219C42B-2B0B-CE41-7DC9-818213E9979A}"/>
+                <a16:creationId xmlns:a16="http://schemas.microsoft.com/office/drawing/2014/main" id="{543BD890-C0F7-9D41-592C-88BB172A97A6}"/>
               </a:ext>
             </a:extLst>
           </p:cNvPr>
@@ -30566,7 +30566,7 @@
           <p:cNvPr id="37" name="icon">
             <a:extLst>
               <a:ext uri="{FF2B5EF4-FFF2-40B4-BE49-F238E27FC236}">
-                <a16:creationId xmlns:a16="http://schemas.microsoft.com/office/drawing/2014/main" id="{CEF8B0D1-CB06-F65F-2D34-C42EB5E5AF29}"/>
+                <a16:creationId xmlns:a16="http://schemas.microsoft.com/office/drawing/2014/main" id="{F45D4589-4B56-EBE0-420E-4CD0650CB294}"/>
               </a:ext>
             </a:extLst>
           </p:cNvPr>
@@ -32343,7 +32343,7 @@
           <p:cNvPr id="3" name="icon">
             <a:extLst>
               <a:ext uri="{FF2B5EF4-FFF2-40B4-BE49-F238E27FC236}">
-                <a16:creationId xmlns:a16="http://schemas.microsoft.com/office/drawing/2014/main" id="{F1D7A1DC-82E5-C1A8-0920-DFC58E58EC7D}"/>
+                <a16:creationId xmlns:a16="http://schemas.microsoft.com/office/drawing/2014/main" id="{BE4CA2F7-3D5E-C033-7719-EED4076CA39C}"/>
               </a:ext>
             </a:extLst>
           </p:cNvPr>
@@ -32379,7 +32379,7 @@
           <p:cNvPr id="5" name="icon">
             <a:extLst>
               <a:ext uri="{FF2B5EF4-FFF2-40B4-BE49-F238E27FC236}">
-                <a16:creationId xmlns:a16="http://schemas.microsoft.com/office/drawing/2014/main" id="{FFCB7DAA-E777-531F-6853-05108A5CF6DD}"/>
+                <a16:creationId xmlns:a16="http://schemas.microsoft.com/office/drawing/2014/main" id="{A0013A77-0336-312E-4A0E-8D155AA18804}"/>
               </a:ext>
             </a:extLst>
           </p:cNvPr>
@@ -32415,7 +32415,7 @@
           <p:cNvPr id="7" name="icon">
             <a:extLst>
               <a:ext uri="{FF2B5EF4-FFF2-40B4-BE49-F238E27FC236}">
-                <a16:creationId xmlns:a16="http://schemas.microsoft.com/office/drawing/2014/main" id="{1B2AF2B5-F3F0-8DFE-B39E-A920617FE0A6}"/>
+                <a16:creationId xmlns:a16="http://schemas.microsoft.com/office/drawing/2014/main" id="{C946763D-0AB2-DEF6-25DF-7AB936981ECA}"/>
               </a:ext>
             </a:extLst>
           </p:cNvPr>
@@ -32451,7 +32451,7 @@
           <p:cNvPr id="9" name="icon">
             <a:extLst>
               <a:ext uri="{FF2B5EF4-FFF2-40B4-BE49-F238E27FC236}">
-                <a16:creationId xmlns:a16="http://schemas.microsoft.com/office/drawing/2014/main" id="{754F230B-DF04-CF5C-9246-1631B7AB1928}"/>
+                <a16:creationId xmlns:a16="http://schemas.microsoft.com/office/drawing/2014/main" id="{521635D4-9B84-AD68-438D-84CB4B1E4856}"/>
               </a:ext>
             </a:extLst>
           </p:cNvPr>
@@ -34346,7 +34346,7 @@
                 </a:solidFill>
                 <a:latin typeface="Consolas"/>
               </a:rPr>
-              <a:t>Dockerfile · docker-compose.yml · results.jsonl · metrics.md · tests/ (27 gates)</a:t>
+              <a:t>Dockerfile · docker-compose.yml · results.jsonl · metrics.md · tests/ (28 gates)</a:t>
             </a:r>
           </a:p>
         </p:txBody>
@@ -34718,7 +34718,7 @@
                 </a:solidFill>
                 <a:latin typeface="Segoe UI Semibold"/>
               </a:rPr>
-              <a:t>27 gates</a:t>
+              <a:t>28 gates</a:t>
             </a:r>
           </a:p>
           <a:p>
@@ -34836,7 +34836,7 @@
           <p:cNvPr id="3" name="icon">
             <a:extLst>
               <a:ext uri="{FF2B5EF4-FFF2-40B4-BE49-F238E27FC236}">
-                <a16:creationId xmlns:a16="http://schemas.microsoft.com/office/drawing/2014/main" id="{4A8E1117-BA08-3090-F8AE-342EE88D446B}"/>
+                <a16:creationId xmlns:a16="http://schemas.microsoft.com/office/drawing/2014/main" id="{88AFF23C-C2CC-27F6-876E-9A480995E7AB}"/>
               </a:ext>
             </a:extLst>
           </p:cNvPr>
@@ -34872,7 +34872,7 @@
           <p:cNvPr id="5" name="icon">
             <a:extLst>
               <a:ext uri="{FF2B5EF4-FFF2-40B4-BE49-F238E27FC236}">
-                <a16:creationId xmlns:a16="http://schemas.microsoft.com/office/drawing/2014/main" id="{11D21F90-64DC-DA85-1FF1-767F356FECC1}"/>
+                <a16:creationId xmlns:a16="http://schemas.microsoft.com/office/drawing/2014/main" id="{3004A3F8-5BED-EA12-6E54-B7DB5AF5EBDD}"/>
               </a:ext>
             </a:extLst>
           </p:cNvPr>
@@ -34908,7 +34908,7 @@
           <p:cNvPr id="7" name="icon">
             <a:extLst>
               <a:ext uri="{FF2B5EF4-FFF2-40B4-BE49-F238E27FC236}">
-                <a16:creationId xmlns:a16="http://schemas.microsoft.com/office/drawing/2014/main" id="{CBCBFBC4-6F1D-3F26-98C6-840020C03F60}"/>
+                <a16:creationId xmlns:a16="http://schemas.microsoft.com/office/drawing/2014/main" id="{7BCE1176-C6B0-B645-9662-197D1A15ABC8}"/>
               </a:ext>
             </a:extLst>
           </p:cNvPr>
@@ -34944,7 +34944,7 @@
           <p:cNvPr id="9" name="icon">
             <a:extLst>
               <a:ext uri="{FF2B5EF4-FFF2-40B4-BE49-F238E27FC236}">
-                <a16:creationId xmlns:a16="http://schemas.microsoft.com/office/drawing/2014/main" id="{FB3C55D4-5A62-9308-A494-62A0343AD9D4}"/>
+                <a16:creationId xmlns:a16="http://schemas.microsoft.com/office/drawing/2014/main" id="{300BA48C-5810-912D-CDFA-1F89B8DC04E7}"/>
               </a:ext>
             </a:extLst>
           </p:cNvPr>
@@ -34980,7 +34980,7 @@
           <p:cNvPr id="11" name="icon">
             <a:extLst>
               <a:ext uri="{FF2B5EF4-FFF2-40B4-BE49-F238E27FC236}">
-                <a16:creationId xmlns:a16="http://schemas.microsoft.com/office/drawing/2014/main" id="{E05F72F3-00CF-A239-7EF7-A82790F1AD94}"/>
+                <a16:creationId xmlns:a16="http://schemas.microsoft.com/office/drawing/2014/main" id="{C3DFAEBF-C647-105F-C736-F668BBC70801}"/>
               </a:ext>
             </a:extLst>
           </p:cNvPr>
@@ -35016,7 +35016,7 @@
           <p:cNvPr id="13" name="icon">
             <a:extLst>
               <a:ext uri="{FF2B5EF4-FFF2-40B4-BE49-F238E27FC236}">
-                <a16:creationId xmlns:a16="http://schemas.microsoft.com/office/drawing/2014/main" id="{E20F3A27-0CC2-2F8B-81BF-9008F5B35572}"/>
+                <a16:creationId xmlns:a16="http://schemas.microsoft.com/office/drawing/2014/main" id="{104A716C-1E95-70E1-0D30-90E4C9F88254}"/>
               </a:ext>
             </a:extLst>
           </p:cNvPr>
@@ -35052,7 +35052,7 @@
           <p:cNvPr id="15" name="icon">
             <a:extLst>
               <a:ext uri="{FF2B5EF4-FFF2-40B4-BE49-F238E27FC236}">
-                <a16:creationId xmlns:a16="http://schemas.microsoft.com/office/drawing/2014/main" id="{86B16C5C-13C9-D663-B7DD-34E987541A96}"/>
+                <a16:creationId xmlns:a16="http://schemas.microsoft.com/office/drawing/2014/main" id="{3A1470F5-9037-F93C-D134-9503E49EE318}"/>
               </a:ext>
             </a:extLst>
           </p:cNvPr>
@@ -35088,7 +35088,7 @@
           <p:cNvPr id="17" name="icon">
             <a:extLst>
               <a:ext uri="{FF2B5EF4-FFF2-40B4-BE49-F238E27FC236}">
-                <a16:creationId xmlns:a16="http://schemas.microsoft.com/office/drawing/2014/main" id="{737FF397-B9B4-9859-0CFC-92F78FC0CA10}"/>
+                <a16:creationId xmlns:a16="http://schemas.microsoft.com/office/drawing/2014/main" id="{1F89C164-066C-2180-6E5D-18772C1124C5}"/>
               </a:ext>
             </a:extLst>
           </p:cNvPr>
@@ -35124,7 +35124,7 @@
           <p:cNvPr id="19" name="icon">
             <a:extLst>
               <a:ext uri="{FF2B5EF4-FFF2-40B4-BE49-F238E27FC236}">
-                <a16:creationId xmlns:a16="http://schemas.microsoft.com/office/drawing/2014/main" id="{EE335B70-256C-3B83-CF8D-2DDE9770A7BB}"/>
+                <a16:creationId xmlns:a16="http://schemas.microsoft.com/office/drawing/2014/main" id="{D73230AA-CF12-9427-7055-4D87AD76D80B}"/>
               </a:ext>
             </a:extLst>
           </p:cNvPr>
@@ -35160,7 +35160,7 @@
           <p:cNvPr id="21" name="icon">
             <a:extLst>
               <a:ext uri="{FF2B5EF4-FFF2-40B4-BE49-F238E27FC236}">
-                <a16:creationId xmlns:a16="http://schemas.microsoft.com/office/drawing/2014/main" id="{378A263E-17BA-92C0-50A0-64E80FADC396}"/>
+                <a16:creationId xmlns:a16="http://schemas.microsoft.com/office/drawing/2014/main" id="{EB4DBB4B-7CA8-4EA7-D9A3-26245E5E1F32}"/>
               </a:ext>
             </a:extLst>
           </p:cNvPr>
@@ -35196,7 +35196,7 @@
           <p:cNvPr id="23" name="icon">
             <a:extLst>
               <a:ext uri="{FF2B5EF4-FFF2-40B4-BE49-F238E27FC236}">
-                <a16:creationId xmlns:a16="http://schemas.microsoft.com/office/drawing/2014/main" id="{7494D3A2-87DE-F7C0-9EDF-9EA520A8DFEE}"/>
+                <a16:creationId xmlns:a16="http://schemas.microsoft.com/office/drawing/2014/main" id="{4DC4D87F-556A-3C43-4216-45F5A1CC9548}"/>
               </a:ext>
             </a:extLst>
           </p:cNvPr>
@@ -35232,7 +35232,7 @@
           <p:cNvPr id="25" name="icon">
             <a:extLst>
               <a:ext uri="{FF2B5EF4-FFF2-40B4-BE49-F238E27FC236}">
-                <a16:creationId xmlns:a16="http://schemas.microsoft.com/office/drawing/2014/main" id="{17D65912-689E-023F-A196-30816BBB9937}"/>
+                <a16:creationId xmlns:a16="http://schemas.microsoft.com/office/drawing/2014/main" id="{817EB020-7C98-BADC-D0B5-A36BC14D4F0F}"/>
               </a:ext>
             </a:extLst>
           </p:cNvPr>
@@ -35268,7 +35268,7 @@
           <p:cNvPr id="27" name="icon">
             <a:extLst>
               <a:ext uri="{FF2B5EF4-FFF2-40B4-BE49-F238E27FC236}">
-                <a16:creationId xmlns:a16="http://schemas.microsoft.com/office/drawing/2014/main" id="{A1E94B81-1DA6-DBA0-F3DB-01D064E5FABE}"/>
+                <a16:creationId xmlns:a16="http://schemas.microsoft.com/office/drawing/2014/main" id="{1F6B0ED3-F4BF-9F7A-4E54-89C0873A51DE}"/>
               </a:ext>
             </a:extLst>
           </p:cNvPr>
@@ -35304,7 +35304,7 @@
           <p:cNvPr id="29" name="icon">
             <a:extLst>
               <a:ext uri="{FF2B5EF4-FFF2-40B4-BE49-F238E27FC236}">
-                <a16:creationId xmlns:a16="http://schemas.microsoft.com/office/drawing/2014/main" id="{AF858C00-FF54-06B0-7FEB-50DA4E39EC7D}"/>
+                <a16:creationId xmlns:a16="http://schemas.microsoft.com/office/drawing/2014/main" id="{AD2AD53F-E3C0-3733-2757-5131D6102A2A}"/>
               </a:ext>
             </a:extLst>
           </p:cNvPr>
@@ -35340,7 +35340,7 @@
           <p:cNvPr id="31" name="icon">
             <a:extLst>
               <a:ext uri="{FF2B5EF4-FFF2-40B4-BE49-F238E27FC236}">
-                <a16:creationId xmlns:a16="http://schemas.microsoft.com/office/drawing/2014/main" id="{BE85321F-2195-9282-FE02-7D243DB5F900}"/>
+                <a16:creationId xmlns:a16="http://schemas.microsoft.com/office/drawing/2014/main" id="{8A63A465-CD3E-CD72-0B2C-190C60A50844}"/>
               </a:ext>
             </a:extLst>
           </p:cNvPr>
@@ -35376,7 +35376,7 @@
           <p:cNvPr id="33" name="icon">
             <a:extLst>
               <a:ext uri="{FF2B5EF4-FFF2-40B4-BE49-F238E27FC236}">
-                <a16:creationId xmlns:a16="http://schemas.microsoft.com/office/drawing/2014/main" id="{AACF7240-8E68-F2A6-4705-CDC60C5A8908}"/>
+                <a16:creationId xmlns:a16="http://schemas.microsoft.com/office/drawing/2014/main" id="{4FC19BDD-426B-C207-43F5-9169FCCE8060}"/>
               </a:ext>
             </a:extLst>
           </p:cNvPr>
@@ -35412,7 +35412,7 @@
           <p:cNvPr id="35" name="icon">
             <a:extLst>
               <a:ext uri="{FF2B5EF4-FFF2-40B4-BE49-F238E27FC236}">
-                <a16:creationId xmlns:a16="http://schemas.microsoft.com/office/drawing/2014/main" id="{1A9C2526-0ED5-8296-7399-96AB086B53BF}"/>
+                <a16:creationId xmlns:a16="http://schemas.microsoft.com/office/drawing/2014/main" id="{AF92A600-5C74-53D9-52D0-FB0D7422D6F2}"/>
               </a:ext>
             </a:extLst>
           </p:cNvPr>
@@ -35448,7 +35448,7 @@
           <p:cNvPr id="37" name="icon">
             <a:extLst>
               <a:ext uri="{FF2B5EF4-FFF2-40B4-BE49-F238E27FC236}">
-                <a16:creationId xmlns:a16="http://schemas.microsoft.com/office/drawing/2014/main" id="{195C7F63-7B74-C3B2-7957-31D295E360A3}"/>
+                <a16:creationId xmlns:a16="http://schemas.microsoft.com/office/drawing/2014/main" id="{743F9AAA-4F22-B968-E52B-8B6ED88C4254}"/>
               </a:ext>
             </a:extLst>
           </p:cNvPr>
@@ -37637,7 +37637,7 @@
           <p:cNvPr id="3" name="icon">
             <a:extLst>
               <a:ext uri="{FF2B5EF4-FFF2-40B4-BE49-F238E27FC236}">
-                <a16:creationId xmlns:a16="http://schemas.microsoft.com/office/drawing/2014/main" id="{43A9E920-7758-12CB-0466-89C6D499F09E}"/>
+                <a16:creationId xmlns:a16="http://schemas.microsoft.com/office/drawing/2014/main" id="{B3065546-ED99-7464-F489-BB56460B24F3}"/>
               </a:ext>
             </a:extLst>
           </p:cNvPr>
@@ -37673,7 +37673,7 @@
           <p:cNvPr id="5" name="icon">
             <a:extLst>
               <a:ext uri="{FF2B5EF4-FFF2-40B4-BE49-F238E27FC236}">
-                <a16:creationId xmlns:a16="http://schemas.microsoft.com/office/drawing/2014/main" id="{248268E3-94F8-83FD-E29A-E77AE5540062}"/>
+                <a16:creationId xmlns:a16="http://schemas.microsoft.com/office/drawing/2014/main" id="{4E2D734F-7770-C018-960C-5E26D44C7DA5}"/>
               </a:ext>
             </a:extLst>
           </p:cNvPr>
@@ -37709,7 +37709,7 @@
           <p:cNvPr id="7" name="icon">
             <a:extLst>
               <a:ext uri="{FF2B5EF4-FFF2-40B4-BE49-F238E27FC236}">
-                <a16:creationId xmlns:a16="http://schemas.microsoft.com/office/drawing/2014/main" id="{05B66A59-ED1A-86D3-061F-BB233B8A9ECF}"/>
+                <a16:creationId xmlns:a16="http://schemas.microsoft.com/office/drawing/2014/main" id="{E5952237-6767-2227-9B53-95A02713AE1E}"/>
               </a:ext>
             </a:extLst>
           </p:cNvPr>
@@ -39628,7 +39628,7 @@
           <p:cNvPr id="3" name="icon">
             <a:extLst>
               <a:ext uri="{FF2B5EF4-FFF2-40B4-BE49-F238E27FC236}">
-                <a16:creationId xmlns:a16="http://schemas.microsoft.com/office/drawing/2014/main" id="{FF4DB0C2-61B3-6E88-B37D-9A51263710EB}"/>
+                <a16:creationId xmlns:a16="http://schemas.microsoft.com/office/drawing/2014/main" id="{8DF3A256-43F2-FDE1-ECF4-76ECCAAE2AA1}"/>
               </a:ext>
             </a:extLst>
           </p:cNvPr>
@@ -39664,7 +39664,7 @@
           <p:cNvPr id="5" name="icon">
             <a:extLst>
               <a:ext uri="{FF2B5EF4-FFF2-40B4-BE49-F238E27FC236}">
-                <a16:creationId xmlns:a16="http://schemas.microsoft.com/office/drawing/2014/main" id="{0464105D-E05B-CE57-FD5C-5E8EF91C735B}"/>
+                <a16:creationId xmlns:a16="http://schemas.microsoft.com/office/drawing/2014/main" id="{D8787ACD-92F1-BEBC-39AC-4B8D1A7C8866}"/>
               </a:ext>
             </a:extLst>
           </p:cNvPr>
@@ -39700,7 +39700,7 @@
           <p:cNvPr id="7" name="icon">
             <a:extLst>
               <a:ext uri="{FF2B5EF4-FFF2-40B4-BE49-F238E27FC236}">
-                <a16:creationId xmlns:a16="http://schemas.microsoft.com/office/drawing/2014/main" id="{6561618C-7F34-C63A-85D3-E2EE1085F504}"/>
+                <a16:creationId xmlns:a16="http://schemas.microsoft.com/office/drawing/2014/main" id="{D12B81AC-7084-C87C-197C-A85A3DE515B8}"/>
               </a:ext>
             </a:extLst>
           </p:cNvPr>
@@ -39736,7 +39736,7 @@
           <p:cNvPr id="9" name="icon">
             <a:extLst>
               <a:ext uri="{FF2B5EF4-FFF2-40B4-BE49-F238E27FC236}">
-                <a16:creationId xmlns:a16="http://schemas.microsoft.com/office/drawing/2014/main" id="{42938A7A-E27A-DBDB-B4D1-F0B819BD77E6}"/>
+                <a16:creationId xmlns:a16="http://schemas.microsoft.com/office/drawing/2014/main" id="{1C8B663E-4B99-A874-B40E-BD25E0B25102}"/>
               </a:ext>
             </a:extLst>
           </p:cNvPr>
@@ -39772,7 +39772,7 @@
           <p:cNvPr id="11" name="icon">
             <a:extLst>
               <a:ext uri="{FF2B5EF4-FFF2-40B4-BE49-F238E27FC236}">
-                <a16:creationId xmlns:a16="http://schemas.microsoft.com/office/drawing/2014/main" id="{B69B0165-B5A1-660D-F8E1-D9DC185A14B8}"/>
+                <a16:creationId xmlns:a16="http://schemas.microsoft.com/office/drawing/2014/main" id="{4B031D47-719E-DA1E-3460-7D1ED19A9432}"/>
               </a:ext>
             </a:extLst>
           </p:cNvPr>
@@ -39808,7 +39808,7 @@
           <p:cNvPr id="13" name="icon">
             <a:extLst>
               <a:ext uri="{FF2B5EF4-FFF2-40B4-BE49-F238E27FC236}">
-                <a16:creationId xmlns:a16="http://schemas.microsoft.com/office/drawing/2014/main" id="{CAC4D2E5-9C7C-6104-F528-D820544B88D9}"/>
+                <a16:creationId xmlns:a16="http://schemas.microsoft.com/office/drawing/2014/main" id="{F4B51F29-4F0B-DA59-8481-BF2B6167B002}"/>
               </a:ext>
             </a:extLst>
           </p:cNvPr>
@@ -39844,7 +39844,7 @@
           <p:cNvPr id="15" name="icon">
             <a:extLst>
               <a:ext uri="{FF2B5EF4-FFF2-40B4-BE49-F238E27FC236}">
-                <a16:creationId xmlns:a16="http://schemas.microsoft.com/office/drawing/2014/main" id="{10EB5485-1D09-E37C-1E1D-46FB0C7CDE2A}"/>
+                <a16:creationId xmlns:a16="http://schemas.microsoft.com/office/drawing/2014/main" id="{92BF77CC-1223-EE07-5B4A-64B1267AB55B}"/>
               </a:ext>
             </a:extLst>
           </p:cNvPr>
@@ -39880,7 +39880,7 @@
           <p:cNvPr id="17" name="icon">
             <a:extLst>
               <a:ext uri="{FF2B5EF4-FFF2-40B4-BE49-F238E27FC236}">
-                <a16:creationId xmlns:a16="http://schemas.microsoft.com/office/drawing/2014/main" id="{A095B85F-FF55-19F5-576C-A5202C200FC7}"/>
+                <a16:creationId xmlns:a16="http://schemas.microsoft.com/office/drawing/2014/main" id="{5D739879-2352-3921-1F28-8A035D08697D}"/>
               </a:ext>
             </a:extLst>
           </p:cNvPr>
@@ -39916,7 +39916,7 @@
           <p:cNvPr id="19" name="icon">
             <a:extLst>
               <a:ext uri="{FF2B5EF4-FFF2-40B4-BE49-F238E27FC236}">
-                <a16:creationId xmlns:a16="http://schemas.microsoft.com/office/drawing/2014/main" id="{8CBE65C5-21AC-9138-21B8-D9443615CF26}"/>
+                <a16:creationId xmlns:a16="http://schemas.microsoft.com/office/drawing/2014/main" id="{CC3B802F-067C-27D6-587F-6B04326CE68D}"/>
               </a:ext>
             </a:extLst>
           </p:cNvPr>
@@ -39952,7 +39952,7 @@
           <p:cNvPr id="21" name="icon">
             <a:extLst>
               <a:ext uri="{FF2B5EF4-FFF2-40B4-BE49-F238E27FC236}">
-                <a16:creationId xmlns:a16="http://schemas.microsoft.com/office/drawing/2014/main" id="{E4E7A307-531B-DD81-A6C2-4A0656667B46}"/>
+                <a16:creationId xmlns:a16="http://schemas.microsoft.com/office/drawing/2014/main" id="{782C8426-519F-28BE-9EC4-9CDFB4031F7C}"/>
               </a:ext>
             </a:extLst>
           </p:cNvPr>
@@ -39988,7 +39988,7 @@
           <p:cNvPr id="23" name="icon">
             <a:extLst>
               <a:ext uri="{FF2B5EF4-FFF2-40B4-BE49-F238E27FC236}">
-                <a16:creationId xmlns:a16="http://schemas.microsoft.com/office/drawing/2014/main" id="{CA12A16F-FEE8-626B-B436-8DCE6A398D57}"/>
+                <a16:creationId xmlns:a16="http://schemas.microsoft.com/office/drawing/2014/main" id="{35DF6E1C-6F49-47E8-C55A-DF2E987414F5}"/>
               </a:ext>
             </a:extLst>
           </p:cNvPr>
@@ -40024,7 +40024,7 @@
           <p:cNvPr id="25" name="icon">
             <a:extLst>
               <a:ext uri="{FF2B5EF4-FFF2-40B4-BE49-F238E27FC236}">
-                <a16:creationId xmlns:a16="http://schemas.microsoft.com/office/drawing/2014/main" id="{3E8E151B-5A6F-8244-1AF5-CFEF951D609A}"/>
+                <a16:creationId xmlns:a16="http://schemas.microsoft.com/office/drawing/2014/main" id="{54243EE1-E197-73E7-956B-6E3F7B910289}"/>
               </a:ext>
             </a:extLst>
           </p:cNvPr>
@@ -40060,7 +40060,7 @@
           <p:cNvPr id="27" name="icon">
             <a:extLst>
               <a:ext uri="{FF2B5EF4-FFF2-40B4-BE49-F238E27FC236}">
-                <a16:creationId xmlns:a16="http://schemas.microsoft.com/office/drawing/2014/main" id="{4506AAE8-F852-DAF2-9578-6D808322D2CB}"/>
+                <a16:creationId xmlns:a16="http://schemas.microsoft.com/office/drawing/2014/main" id="{BEACA531-BAE2-A09F-EA7C-3E1A1E2E0E52}"/>
               </a:ext>
             </a:extLst>
           </p:cNvPr>
@@ -40096,7 +40096,7 @@
           <p:cNvPr id="29" name="icon">
             <a:extLst>
               <a:ext uri="{FF2B5EF4-FFF2-40B4-BE49-F238E27FC236}">
-                <a16:creationId xmlns:a16="http://schemas.microsoft.com/office/drawing/2014/main" id="{CCDB0AEA-689E-9FC1-8ECD-1A81870BCF8D}"/>
+                <a16:creationId xmlns:a16="http://schemas.microsoft.com/office/drawing/2014/main" id="{4555051C-8448-B375-FF62-C363768B2AD5}"/>
               </a:ext>
             </a:extLst>
           </p:cNvPr>
@@ -40132,7 +40132,7 @@
           <p:cNvPr id="31" name="icon">
             <a:extLst>
               <a:ext uri="{FF2B5EF4-FFF2-40B4-BE49-F238E27FC236}">
-                <a16:creationId xmlns:a16="http://schemas.microsoft.com/office/drawing/2014/main" id="{588E2553-5DF3-E51A-027E-F700B95C486A}"/>
+                <a16:creationId xmlns:a16="http://schemas.microsoft.com/office/drawing/2014/main" id="{F4E36235-86B3-E87A-D5BA-E815094DC86D}"/>
               </a:ext>
             </a:extLst>
           </p:cNvPr>
@@ -40168,7 +40168,7 @@
           <p:cNvPr id="33" name="icon">
             <a:extLst>
               <a:ext uri="{FF2B5EF4-FFF2-40B4-BE49-F238E27FC236}">
-                <a16:creationId xmlns:a16="http://schemas.microsoft.com/office/drawing/2014/main" id="{D2D5845E-CCE1-3A71-A70A-B7C6B6DEC1A8}"/>
+                <a16:creationId xmlns:a16="http://schemas.microsoft.com/office/drawing/2014/main" id="{20352CF5-8145-9DE6-C21F-B540A19B1512}"/>
               </a:ext>
             </a:extLst>
           </p:cNvPr>
@@ -43140,7 +43140,7 @@
           <p:cNvPr id="3" name="icon">
             <a:extLst>
               <a:ext uri="{FF2B5EF4-FFF2-40B4-BE49-F238E27FC236}">
-                <a16:creationId xmlns:a16="http://schemas.microsoft.com/office/drawing/2014/main" id="{B639ECC8-2AF6-45CF-E978-407DEB399464}"/>
+                <a16:creationId xmlns:a16="http://schemas.microsoft.com/office/drawing/2014/main" id="{E4E30C2D-BD9F-1B29-45D4-BD1F5D64285F}"/>
               </a:ext>
             </a:extLst>
           </p:cNvPr>
@@ -43176,7 +43176,7 @@
           <p:cNvPr id="5" name="icon">
             <a:extLst>
               <a:ext uri="{FF2B5EF4-FFF2-40B4-BE49-F238E27FC236}">
-                <a16:creationId xmlns:a16="http://schemas.microsoft.com/office/drawing/2014/main" id="{2B428B7D-1D3E-C0FA-BF91-5578E78CE542}"/>
+                <a16:creationId xmlns:a16="http://schemas.microsoft.com/office/drawing/2014/main" id="{64EC730B-E7A5-FEB4-6A8E-AF5E0A2B71FB}"/>
               </a:ext>
             </a:extLst>
           </p:cNvPr>
@@ -43212,7 +43212,7 @@
           <p:cNvPr id="7" name="icon">
             <a:extLst>
               <a:ext uri="{FF2B5EF4-FFF2-40B4-BE49-F238E27FC236}">
-                <a16:creationId xmlns:a16="http://schemas.microsoft.com/office/drawing/2014/main" id="{7C1DD288-33E1-6C6F-4665-B390910A1C45}"/>
+                <a16:creationId xmlns:a16="http://schemas.microsoft.com/office/drawing/2014/main" id="{E5DCBA78-8BE0-447E-4F86-B0C8FDB3D428}"/>
               </a:ext>
             </a:extLst>
           </p:cNvPr>
@@ -43248,7 +43248,7 @@
           <p:cNvPr id="9" name="icon">
             <a:extLst>
               <a:ext uri="{FF2B5EF4-FFF2-40B4-BE49-F238E27FC236}">
-                <a16:creationId xmlns:a16="http://schemas.microsoft.com/office/drawing/2014/main" id="{87EE6626-CBBB-F9F6-0561-62C842595260}"/>
+                <a16:creationId xmlns:a16="http://schemas.microsoft.com/office/drawing/2014/main" id="{B86E45DB-B2D9-5C90-0656-4B18CE1C8B10}"/>
               </a:ext>
             </a:extLst>
           </p:cNvPr>
@@ -43284,7 +43284,7 @@
           <p:cNvPr id="11" name="icon">
             <a:extLst>
               <a:ext uri="{FF2B5EF4-FFF2-40B4-BE49-F238E27FC236}">
-                <a16:creationId xmlns:a16="http://schemas.microsoft.com/office/drawing/2014/main" id="{B7D77599-B28A-BE2D-F79D-D9F464304D40}"/>
+                <a16:creationId xmlns:a16="http://schemas.microsoft.com/office/drawing/2014/main" id="{49B52A28-F01F-3C92-2B54-9A379B296358}"/>
               </a:ext>
             </a:extLst>
           </p:cNvPr>

</xml_diff>